<commit_message>
Update results and figures: modify accuracy metrics, add new binary files, and adjust epsilon sweep data
</commit_message>
<xml_diff>
--- a/docs/Презентация.pptx
+++ b/docs/Презентация.pptx
@@ -4,6 +4,9 @@
   <p:sldMasterIdLst>
     <p:sldMasterId id="2147483648" r:id="rId1"/>
   </p:sldMasterIdLst>
+  <p:notesMasterIdLst>
+    <p:notesMasterId r:id="rId16"/>
+  </p:notesMasterIdLst>
   <p:sldIdLst>
     <p:sldId id="256" r:id="rId2"/>
     <p:sldId id="257" r:id="rId3"/>
@@ -20,11 +23,8 @@
     <p:sldId id="268" r:id="rId14"/>
     <p:sldId id="269" r:id="rId15"/>
   </p:sldIdLst>
-  <p:notesMasterIdLst>
-    <p:notesMasterId r:id="rId16"/>
-  </p:notesMasterIdLst>
-  <p:sldSz cx="12188952" cy="6858000"/>
-  <p:notesSz cx="6858000" cy="12188952"/>
+  <p:sldSz cx="12188825" cy="6858000"/>
+  <p:notesSz cx="6858000" cy="12188825"/>
   <p:defaultTextStyle>
     <a:lvl1pPr marL="0" algn="l" defTabSz="914400" rtl="0" eaLnBrk="1" latinLnBrk="0" hangingPunct="1">
       <a:defRPr sz="1800" kern="1200">
@@ -117,6 +117,11 @@
       </a:defRPr>
     </a:lvl9pPr>
   </p:defaultTextStyle>
+  <p:extLst>
+    <p:ext uri="{EFAFB233-063F-42B5-8137-9DF3F51BA10A}">
+      <p15:sldGuideLst xmlns:p15="http://schemas.microsoft.com/office/powerpoint/2012/main"/>
+    </p:ext>
+  </p:extLst>
 </p:presentation>
 </file>
 
@@ -142,234 +147,10 @@
           <a:chExt cx="0" cy="0"/>
         </a:xfrm>
       </p:grpSpPr>
-      <p:sp>
-        <p:nvSpPr>
-          <p:cNvPr id="2" name="Header Placeholder 1"/>
-          <p:cNvSpPr>
-            <a:spLocks noGrp="1"/>
-          </p:cNvSpPr>
-          <p:nvPr>
-            <p:ph type="hdr" sz="quarter"/>
-          </p:nvPr>
-        </p:nvSpPr>
-        <p:spPr>
-          <a:xfrm>
-            <a:off x="0" y="0"/>
-            <a:ext cx="2971800" cy="458788"/>
-          </a:xfrm>
-          <a:prstGeom prst="rect">
-            <a:avLst/>
-          </a:prstGeom>
-        </p:spPr>
-        <p:txBody>
-          <a:bodyPr vert="horz" lIns="91440" tIns="45720" rIns="91440" bIns="45720" rtlCol="0"/>
-          <a:lstStyle>
-            <a:lvl1pPr algn="l">
-              <a:defRPr sz="1200"/>
-            </a:lvl1pPr>
-          </a:lstStyle>
-          <a:p>
-            <a:endParaRPr lang="en-US"/>
-          </a:p>
-        </p:txBody>
-      </p:sp>
-      <p:sp>
-        <p:nvSpPr>
-          <p:cNvPr id="3" name="Date Placeholder 2"/>
-          <p:cNvSpPr>
-            <a:spLocks noGrp="1"/>
-          </p:cNvSpPr>
-          <p:nvPr>
-            <p:ph type="dt" idx="1"/>
-          </p:nvPr>
-        </p:nvSpPr>
-        <p:spPr>
-          <a:xfrm>
-            <a:off x="3884613" y="0"/>
-            <a:ext cx="2971800" cy="458788"/>
-          </a:xfrm>
-          <a:prstGeom prst="rect">
-            <a:avLst/>
-          </a:prstGeom>
-        </p:spPr>
-        <p:txBody>
-          <a:bodyPr vert="horz" lIns="91440" tIns="45720" rIns="91440" bIns="45720" rtlCol="0"/>
-          <a:lstStyle>
-            <a:lvl1pPr algn="r">
-              <a:defRPr sz="1200"/>
-            </a:lvl1pPr>
-          </a:lstStyle>
-          <a:p>
-            <a:fld id="{5282F153-3F37-0F45-9E97-73ACFA13230C}" type="datetimeFigureOut">
-              <a:rPr lang="en-US"/>
-              <a:t>7/23/19</a:t>
-            </a:fld>
-            <a:endParaRPr lang="en-US"/>
-          </a:p>
-        </p:txBody>
-      </p:sp>
-      <p:sp>
-        <p:nvSpPr>
-          <p:cNvPr id="4" name="Slide Image Placeholder 3"/>
-          <p:cNvSpPr>
-            <a:spLocks noGrp="1" noRot="1" noChangeAspect="1"/>
-          </p:cNvSpPr>
-          <p:nvPr>
-            <p:ph type="sldImg" idx="2"/>
-          </p:nvPr>
-        </p:nvSpPr>
-        <p:spPr>
-          <a:xfrm>
-            <a:off x="685800" y="1143000"/>
-            <a:ext cx="5486400" cy="3086100"/>
-          </a:xfrm>
-          <a:prstGeom prst="rect">
-            <a:avLst/>
-          </a:prstGeom>
-          <a:noFill/>
-          <a:ln w="12700">
-            <a:solidFill>
-              <a:prstClr val="black"/>
-            </a:solidFill>
-          </a:ln>
-        </p:spPr>
-        <p:txBody>
-          <a:bodyPr vert="horz" lIns="91440" tIns="45720" rIns="91440" bIns="45720" rtlCol="0" anchor="ctr"/>
-          <a:lstStyle/>
-          <a:p>
-            <a:endParaRPr lang="en-US"/>
-          </a:p>
-        </p:txBody>
-      </p:sp>
-      <p:sp>
-        <p:nvSpPr>
-          <p:cNvPr id="5" name="Notes Placeholder 4"/>
-          <p:cNvSpPr>
-            <a:spLocks noGrp="1"/>
-          </p:cNvSpPr>
-          <p:nvPr>
-            <p:ph type="body" sz="quarter" idx="3"/>
-          </p:nvPr>
-        </p:nvSpPr>
-        <p:spPr>
-          <a:xfrm>
-            <a:off x="685800" y="4400550"/>
-            <a:ext cx="5486400" cy="3600450"/>
-          </a:xfrm>
-          <a:prstGeom prst="rect">
-            <a:avLst/>
-          </a:prstGeom>
-        </p:spPr>
-        <p:txBody>
-          <a:bodyPr vert="horz" lIns="91440" tIns="45720" rIns="91440" bIns="45720" rtlCol="0"/>
-          <a:lstStyle/>
-          <a:p>
-            <a:pPr lvl="0"/>
-            <a:r>
-              <a:rPr lang="en-US"/>
-              <a:t>Click to edit Master text styles</a:t>
-            </a:r>
-          </a:p>
-          <a:p>
-            <a:pPr lvl="1"/>
-            <a:r>
-              <a:rPr lang="en-US"/>
-              <a:t>Second level</a:t>
-            </a:r>
-          </a:p>
-          <a:p>
-            <a:pPr lvl="2"/>
-            <a:r>
-              <a:rPr lang="en-US"/>
-              <a:t>Third level</a:t>
-            </a:r>
-          </a:p>
-          <a:p>
-            <a:pPr lvl="3"/>
-            <a:r>
-              <a:rPr lang="en-US"/>
-              <a:t>Fourth level</a:t>
-            </a:r>
-          </a:p>
-          <a:p>
-            <a:pPr lvl="4"/>
-            <a:r>
-              <a:rPr lang="en-US"/>
-              <a:t>Fifth level</a:t>
-            </a:r>
-          </a:p>
-        </p:txBody>
-      </p:sp>
-      <p:sp>
-        <p:nvSpPr>
-          <p:cNvPr id="6" name="Footer Placeholder 5"/>
-          <p:cNvSpPr>
-            <a:spLocks noGrp="1"/>
-          </p:cNvSpPr>
-          <p:nvPr>
-            <p:ph type="ftr" sz="quarter" idx="4"/>
-          </p:nvPr>
-        </p:nvSpPr>
-        <p:spPr>
-          <a:xfrm>
-            <a:off x="0" y="8685213"/>
-            <a:ext cx="2971800" cy="458787"/>
-          </a:xfrm>
-          <a:prstGeom prst="rect">
-            <a:avLst/>
-          </a:prstGeom>
-        </p:spPr>
-        <p:txBody>
-          <a:bodyPr vert="horz" lIns="91440" tIns="45720" rIns="91440" bIns="45720" rtlCol="0" anchor="b"/>
-          <a:lstStyle>
-            <a:lvl1pPr algn="l">
-              <a:defRPr sz="1200"/>
-            </a:lvl1pPr>
-          </a:lstStyle>
-          <a:p>
-            <a:endParaRPr lang="en-US"/>
-          </a:p>
-        </p:txBody>
-      </p:sp>
-      <p:sp>
-        <p:nvSpPr>
-          <p:cNvPr id="7" name="Slide Number Placeholder 6"/>
-          <p:cNvSpPr>
-            <a:spLocks noGrp="1"/>
-          </p:cNvSpPr>
-          <p:nvPr>
-            <p:ph type="sldNum" sz="quarter" idx="5"/>
-          </p:nvPr>
-        </p:nvSpPr>
-        <p:spPr>
-          <a:xfrm>
-            <a:off x="3884613" y="8685213"/>
-            <a:ext cx="2971800" cy="458787"/>
-          </a:xfrm>
-          <a:prstGeom prst="rect">
-            <a:avLst/>
-          </a:prstGeom>
-        </p:spPr>
-        <p:txBody>
-          <a:bodyPr vert="horz" lIns="91440" tIns="45720" rIns="91440" bIns="45720" rtlCol="0" anchor="b"/>
-          <a:lstStyle>
-            <a:lvl1pPr algn="r">
-              <a:defRPr sz="1200"/>
-            </a:lvl1pPr>
-          </a:lstStyle>
-          <a:p>
-            <a:fld id="{CE5E9CC1-C706-0F49-92D6-E571CC5EEA8F}" type="slidenum">
-              <a:rPr lang="en-US"/>
-              <a:t>‹#›</a:t>
-            </a:fld>
-            <a:endParaRPr lang="en-US"/>
-          </a:p>
-        </p:txBody>
-      </p:sp>
     </p:spTree>
     <p:extLst>
       <p:ext uri="{BB962C8B-B14F-4D97-AF65-F5344CB8AC3E}">
-        <p14:creationId xmlns:p14="http://schemas.microsoft.com/office/powerpoint/2010/main" val="1024086991"/>
+        <p14:creationId xmlns:p14="http://schemas.microsoft.com/office/powerpoint/2010/main" val="3741272151"/>
       </p:ext>
     </p:extLst>
   </p:cSld>
@@ -513,10 +294,6 @@
           <a:bodyPr/>
           <a:lstStyle/>
           <a:p>
-            <a:r>
-              <a:rPr lang="en-US" dirty="0"/>
-              <a:t/>
-            </a:r>
             <a:endParaRPr lang="en-US" dirty="0"/>
           </a:p>
         </p:txBody>
@@ -601,10 +378,6 @@
           <a:bodyPr/>
           <a:lstStyle/>
           <a:p>
-            <a:r>
-              <a:rPr lang="en-US" dirty="0"/>
-              <a:t/>
-            </a:r>
             <a:endParaRPr lang="en-US" dirty="0"/>
           </a:p>
         </p:txBody>
@@ -689,10 +462,6 @@
           <a:bodyPr/>
           <a:lstStyle/>
           <a:p>
-            <a:r>
-              <a:rPr lang="en-US" dirty="0"/>
-              <a:t/>
-            </a:r>
             <a:endParaRPr lang="en-US" dirty="0"/>
           </a:p>
         </p:txBody>
@@ -777,10 +546,6 @@
           <a:bodyPr/>
           <a:lstStyle/>
           <a:p>
-            <a:r>
-              <a:rPr lang="en-US" dirty="0"/>
-              <a:t/>
-            </a:r>
             <a:endParaRPr lang="en-US" dirty="0"/>
           </a:p>
         </p:txBody>
@@ -865,10 +630,6 @@
           <a:bodyPr/>
           <a:lstStyle/>
           <a:p>
-            <a:r>
-              <a:rPr lang="en-US" dirty="0"/>
-              <a:t/>
-            </a:r>
             <a:endParaRPr lang="en-US" dirty="0"/>
           </a:p>
         </p:txBody>
@@ -953,10 +714,6 @@
           <a:bodyPr/>
           <a:lstStyle/>
           <a:p>
-            <a:r>
-              <a:rPr lang="en-US" dirty="0"/>
-              <a:t/>
-            </a:r>
             <a:endParaRPr lang="en-US" dirty="0"/>
           </a:p>
         </p:txBody>
@@ -1041,10 +798,6 @@
           <a:bodyPr/>
           <a:lstStyle/>
           <a:p>
-            <a:r>
-              <a:rPr lang="en-US" dirty="0"/>
-              <a:t/>
-            </a:r>
             <a:endParaRPr lang="en-US" dirty="0"/>
           </a:p>
         </p:txBody>
@@ -1129,10 +882,6 @@
           <a:bodyPr/>
           <a:lstStyle/>
           <a:p>
-            <a:r>
-              <a:rPr lang="en-US" dirty="0"/>
-              <a:t/>
-            </a:r>
             <a:endParaRPr lang="en-US" dirty="0"/>
           </a:p>
         </p:txBody>
@@ -1217,10 +966,6 @@
           <a:bodyPr/>
           <a:lstStyle/>
           <a:p>
-            <a:r>
-              <a:rPr lang="en-US" dirty="0"/>
-              <a:t/>
-            </a:r>
             <a:endParaRPr lang="en-US" dirty="0"/>
           </a:p>
         </p:txBody>
@@ -1305,10 +1050,6 @@
           <a:bodyPr/>
           <a:lstStyle/>
           <a:p>
-            <a:r>
-              <a:rPr lang="en-US" dirty="0"/>
-              <a:t/>
-            </a:r>
             <a:endParaRPr lang="en-US" dirty="0"/>
           </a:p>
         </p:txBody>
@@ -1393,10 +1134,6 @@
           <a:bodyPr/>
           <a:lstStyle/>
           <a:p>
-            <a:r>
-              <a:rPr lang="en-US" dirty="0"/>
-              <a:t/>
-            </a:r>
             <a:endParaRPr lang="en-US" dirty="0"/>
           </a:p>
         </p:txBody>
@@ -1481,10 +1218,6 @@
           <a:bodyPr/>
           <a:lstStyle/>
           <a:p>
-            <a:r>
-              <a:rPr lang="en-US" dirty="0"/>
-              <a:t/>
-            </a:r>
             <a:endParaRPr lang="en-US" dirty="0"/>
           </a:p>
         </p:txBody>
@@ -1569,10 +1302,6 @@
           <a:bodyPr/>
           <a:lstStyle/>
           <a:p>
-            <a:r>
-              <a:rPr lang="en-US" dirty="0"/>
-              <a:t/>
-            </a:r>
             <a:endParaRPr lang="en-US" dirty="0"/>
           </a:p>
         </p:txBody>
@@ -1657,10 +1386,6 @@
           <a:bodyPr/>
           <a:lstStyle/>
           <a:p>
-            <a:r>
-              <a:rPr lang="en-US" dirty="0"/>
-              <a:t/>
-            </a:r>
             <a:endParaRPr lang="en-US" dirty="0"/>
           </a:p>
         </p:txBody>
@@ -1734,6 +1459,11 @@
 <file path=ppt/slideMasters/slideMaster1.xml><?xml version="1.0" encoding="utf-8"?>
 <p:sldMaster xmlns:a="http://schemas.openxmlformats.org/drawingml/2006/main" xmlns:r="http://schemas.openxmlformats.org/officeDocument/2006/relationships" xmlns:p="http://schemas.openxmlformats.org/presentationml/2006/main">
   <p:cSld>
+    <p:bg>
+      <p:bgRef idx="1001">
+        <a:schemeClr val="bg1"/>
+      </p:bgRef>
+    </p:bg>
     <p:spTree>
       <p:nvGrpSpPr>
         <p:cNvPr id="1" name=""/>
@@ -2016,6 +1746,7 @@
         <a:solidFill>
           <a:srgbClr val="0E1E40"/>
         </a:solidFill>
+        <a:effectLst/>
       </p:bgPr>
     </p:bg>
     <p:spTree>
@@ -2051,6 +1782,13 @@
           </a:solidFill>
           <a:ln/>
         </p:spPr>
+        <p:txBody>
+          <a:bodyPr/>
+          <a:lstStyle/>
+          <a:p>
+            <a:endParaRPr lang="ru-RU"/>
+          </a:p>
+        </p:txBody>
       </p:sp>
       <p:sp>
         <p:nvSpPr>
@@ -2071,6 +1809,13 @@
           </a:solidFill>
           <a:ln/>
         </p:spPr>
+        <p:txBody>
+          <a:bodyPr/>
+          <a:lstStyle/>
+          <a:p>
+            <a:endParaRPr lang="ru-RU"/>
+          </a:p>
+        </p:txBody>
       </p:sp>
       <p:sp>
         <p:nvSpPr>
@@ -2093,7 +1838,7 @@
           <a:bodyPr wrap="square" rtlCol="0" anchor="ctr"/>
           <a:lstStyle/>
           <a:p>
-            <a:pPr indent="0" marL="0">
+            <a:pPr marL="0" indent="0">
               <a:lnSpc>
                 <a:spcPct val="105000"/>
               </a:lnSpc>
@@ -2113,7 +1858,7 @@
             <a:endParaRPr lang="en-US" sz="4000" dirty="0"/>
           </a:p>
           <a:p>
-            <a:pPr indent="0" marL="0">
+            <a:pPr marL="0" indent="0">
               <a:lnSpc>
                 <a:spcPct val="105000"/>
               </a:lnSpc>
@@ -2155,7 +1900,7 @@
           <a:bodyPr wrap="square" rtlCol="0" anchor="ctr"/>
           <a:lstStyle/>
           <a:p>
-            <a:pPr indent="0" marL="0">
+            <a:pPr marL="0" indent="0">
               <a:buNone/>
             </a:pPr>
             <a:r>
@@ -2192,13 +1937,20 @@
           </a:solidFill>
           <a:ln/>
           <a:effectLst>
-            <a:outerShdw sx="100000" sy="100000" kx="0" ky="0" algn="bl" rotWithShape="0" blurRad="114300" dist="38100" dir="5400000">
+            <a:outerShdw blurRad="114300" dist="38100" dir="5400000" algn="bl" rotWithShape="0">
               <a:srgbClr val="0A1430">
                 <a:alpha val="18000"/>
               </a:srgbClr>
             </a:outerShdw>
           </a:effectLst>
         </p:spPr>
+        <p:txBody>
+          <a:bodyPr/>
+          <a:lstStyle/>
+          <a:p>
+            <a:endParaRPr lang="ru-RU"/>
+          </a:p>
+        </p:txBody>
       </p:sp>
       <p:sp>
         <p:nvSpPr>
@@ -2219,13 +1971,20 @@
           </a:solidFill>
           <a:ln/>
           <a:effectLst>
-            <a:outerShdw sx="100000" sy="100000" kx="0" ky="0" algn="bl" rotWithShape="0" blurRad="114300" dist="38100" dir="5400000">
+            <a:outerShdw blurRad="114300" dist="38100" dir="5400000" algn="bl" rotWithShape="0">
               <a:srgbClr val="0A1430">
                 <a:alpha val="18000"/>
               </a:srgbClr>
             </a:outerShdw>
           </a:effectLst>
         </p:spPr>
+        <p:txBody>
+          <a:bodyPr/>
+          <a:lstStyle/>
+          <a:p>
+            <a:endParaRPr lang="ru-RU"/>
+          </a:p>
+        </p:txBody>
       </p:sp>
       <p:sp>
         <p:nvSpPr>
@@ -2248,7 +2007,7 @@
           <a:bodyPr wrap="square" lIns="0" tIns="0" rIns="0" bIns="0" rtlCol="0" anchor="ctr"/>
           <a:lstStyle/>
           <a:p>
-            <a:pPr indent="0" marL="0">
+            <a:pPr marL="0" indent="0">
               <a:buNone/>
             </a:pPr>
             <a:r>
@@ -2287,7 +2046,7 @@
           <a:bodyPr wrap="square" rtlCol="0" anchor="ctr"/>
           <a:lstStyle/>
           <a:p>
-            <a:pPr indent="0" marL="0">
+            <a:pPr marL="0" indent="0">
               <a:buNone/>
             </a:pPr>
             <a:r>
@@ -2304,7 +2063,7 @@
             <a:endParaRPr lang="en-US" sz="1400" dirty="0"/>
           </a:p>
           <a:p>
-            <a:pPr indent="0" marL="0">
+            <a:pPr marL="0" indent="0">
               <a:buNone/>
             </a:pPr>
             <a:r>
@@ -2316,7 +2075,18 @@
                 <a:ea typeface="Calibri" pitchFamily="34" charset="-122"/>
                 <a:cs typeface="Calibri" pitchFamily="34" charset="-120"/>
               </a:rPr>
-              <a:t>Выполнил: [ФИО студента]</a:t>
+              <a:t>Выполнил: </a:t>
+            </a:r>
+            <a:r>
+              <a:rPr lang="ru-RU" sz="1400" dirty="0">
+                <a:solidFill>
+                  <a:srgbClr val="FFFFFF"/>
+                </a:solidFill>
+                <a:latin typeface="Calibri" pitchFamily="34" charset="0"/>
+                <a:ea typeface="Calibri" pitchFamily="34" charset="-122"/>
+                <a:cs typeface="Calibri" pitchFamily="34" charset="-120"/>
+              </a:rPr>
+              <a:t>Забелин Владислав Константинович</a:t>
             </a:r>
             <a:endParaRPr lang="en-US" sz="1400" dirty="0"/>
           </a:p>
@@ -2338,6 +2108,7 @@
         <a:solidFill>
           <a:srgbClr val="F4F6FB"/>
         </a:solidFill>
+        <a:effectLst/>
       </p:bgPr>
     </p:bg>
     <p:spTree>
@@ -2373,6 +2144,13 @@
           </a:solidFill>
           <a:ln/>
         </p:spPr>
+        <p:txBody>
+          <a:bodyPr/>
+          <a:lstStyle/>
+          <a:p>
+            <a:endParaRPr lang="ru-RU"/>
+          </a:p>
+        </p:txBody>
       </p:sp>
       <p:sp>
         <p:nvSpPr>
@@ -2395,7 +2173,7 @@
           <a:bodyPr wrap="square" lIns="0" tIns="0" rIns="0" bIns="0" rtlCol="0" anchor="ctr"/>
           <a:lstStyle/>
           <a:p>
-            <a:pPr indent="0" marL="0">
+            <a:pPr marL="0" indent="0">
               <a:buNone/>
             </a:pPr>
             <a:r>
@@ -2434,7 +2212,7 @@
           <a:bodyPr wrap="square" rtlCol="0" anchor="ctr"/>
           <a:lstStyle/>
           <a:p>
-            <a:pPr algn="r" indent="0" marL="0">
+            <a:pPr marL="0" indent="0" algn="r">
               <a:buNone/>
             </a:pPr>
             <a:r>
@@ -2473,7 +2251,7 @@
           <a:bodyPr wrap="square" rtlCol="0" anchor="ctr"/>
           <a:lstStyle/>
           <a:p>
-            <a:pPr algn="l" indent="0" marL="0">
+            <a:pPr marL="0" indent="0" algn="l">
               <a:buNone/>
             </a:pPr>
             <a:r>
@@ -2512,7 +2290,7 @@
           <a:bodyPr wrap="square" rtlCol="0" anchor="ctr"/>
           <a:lstStyle/>
           <a:p>
-            <a:pPr indent="0" marL="0">
+            <a:pPr marL="0" indent="0">
               <a:buNone/>
             </a:pPr>
             <a:r>
@@ -2554,24 +2332,31 @@
             <a:prstDash val="solid"/>
           </a:ln>
           <a:effectLst>
-            <a:outerShdw sx="100000" sy="100000" kx="0" ky="0" algn="bl" rotWithShape="0" blurRad="114300" dist="38100" dir="5400000">
+            <a:outerShdw blurRad="114300" dist="38100" dir="5400000" algn="bl" rotWithShape="0">
               <a:srgbClr val="0A1430">
                 <a:alpha val="18000"/>
               </a:srgbClr>
             </a:outerShdw>
           </a:effectLst>
         </p:spPr>
+        <p:txBody>
+          <a:bodyPr/>
+          <a:lstStyle/>
+          <a:p>
+            <a:endParaRPr lang="ru-RU"/>
+          </a:p>
+        </p:txBody>
       </p:sp>
       <p:pic>
         <p:nvPicPr>
-          <p:cNvPr id="8" name="Image 0" descr="C:\Users\Kaiba\Desktop\study\project_attack_llm\results\figures\adv_examples_grid.png">    </p:cNvPr>
+          <p:cNvPr id="8" name="Image 0" descr="C:\Users\Kaiba\Desktop\study\project_attack_llm\results\figures\adv_examples_grid.png"/>
           <p:cNvPicPr>
             <a:picLocks noChangeAspect="1"/>
           </p:cNvPicPr>
           <p:nvPr/>
         </p:nvPicPr>
         <p:blipFill>
-          <a:blip r:embed="rId1"/>
+          <a:blip r:embed="rId3"/>
           <a:stretch>
             <a:fillRect/>
           </a:stretch>
@@ -2602,6 +2387,7 @@
         <a:solidFill>
           <a:srgbClr val="F4F6FB"/>
         </a:solidFill>
+        <a:effectLst/>
       </p:bgPr>
     </p:bg>
     <p:spTree>
@@ -2637,6 +2423,13 @@
           </a:solidFill>
           <a:ln/>
         </p:spPr>
+        <p:txBody>
+          <a:bodyPr/>
+          <a:lstStyle/>
+          <a:p>
+            <a:endParaRPr lang="ru-RU"/>
+          </a:p>
+        </p:txBody>
       </p:sp>
       <p:sp>
         <p:nvSpPr>
@@ -2659,7 +2452,7 @@
           <a:bodyPr wrap="square" lIns="0" tIns="0" rIns="0" bIns="0" rtlCol="0" anchor="ctr"/>
           <a:lstStyle/>
           <a:p>
-            <a:pPr indent="0" marL="0">
+            <a:pPr marL="0" indent="0">
               <a:buNone/>
             </a:pPr>
             <a:r>
@@ -2698,7 +2491,7 @@
           <a:bodyPr wrap="square" rtlCol="0" anchor="ctr"/>
           <a:lstStyle/>
           <a:p>
-            <a:pPr algn="r" indent="0" marL="0">
+            <a:pPr marL="0" indent="0" algn="r">
               <a:buNone/>
             </a:pPr>
             <a:r>
@@ -2737,7 +2530,7 @@
           <a:bodyPr wrap="square" rtlCol="0" anchor="ctr"/>
           <a:lstStyle/>
           <a:p>
-            <a:pPr algn="l" indent="0" marL="0">
+            <a:pPr marL="0" indent="0" algn="l">
               <a:buNone/>
             </a:pPr>
             <a:r>
@@ -2779,24 +2572,31 @@
             <a:prstDash val="solid"/>
           </a:ln>
           <a:effectLst>
-            <a:outerShdw sx="100000" sy="100000" kx="0" ky="0" algn="bl" rotWithShape="0" blurRad="114300" dist="38100" dir="5400000">
+            <a:outerShdw blurRad="114300" dist="38100" dir="5400000" algn="bl" rotWithShape="0">
               <a:srgbClr val="0A1430">
                 <a:alpha val="18000"/>
               </a:srgbClr>
             </a:outerShdw>
           </a:effectLst>
         </p:spPr>
+        <p:txBody>
+          <a:bodyPr/>
+          <a:lstStyle/>
+          <a:p>
+            <a:endParaRPr lang="ru-RU"/>
+          </a:p>
+        </p:txBody>
       </p:sp>
       <p:pic>
         <p:nvPicPr>
-          <p:cNvPr id="7" name="Image 0" descr="C:\Users\Kaiba\Desktop\study\project_attack_llm\results\figures\epsilon_sweep.png">    </p:cNvPr>
+          <p:cNvPr id="7" name="Image 0" descr="C:\Users\Kaiba\Desktop\study\project_attack_llm\results\figures\epsilon_sweep.png"/>
           <p:cNvPicPr>
             <a:picLocks noChangeAspect="1"/>
           </p:cNvPicPr>
           <p:nvPr/>
         </p:nvPicPr>
         <p:blipFill>
-          <a:blip r:embed="rId1"/>
+          <a:blip r:embed="rId3"/>
           <a:stretch>
             <a:fillRect/>
           </a:stretch>
@@ -2832,7 +2632,7 @@
           <a:bodyPr wrap="square" rtlCol="0" anchor="ctr"/>
           <a:lstStyle/>
           <a:p>
-            <a:pPr algn="ctr" indent="0" marL="0">
+            <a:pPr marL="0" indent="0" algn="ctr">
               <a:buNone/>
             </a:pPr>
             <a:r>
@@ -2874,24 +2674,31 @@
             <a:prstDash val="solid"/>
           </a:ln>
           <a:effectLst>
-            <a:outerShdw sx="100000" sy="100000" kx="0" ky="0" algn="bl" rotWithShape="0" blurRad="114300" dist="38100" dir="5400000">
+            <a:outerShdw blurRad="114300" dist="38100" dir="5400000" algn="bl" rotWithShape="0">
               <a:srgbClr val="0A1430">
                 <a:alpha val="18000"/>
               </a:srgbClr>
             </a:outerShdw>
           </a:effectLst>
         </p:spPr>
+        <p:txBody>
+          <a:bodyPr/>
+          <a:lstStyle/>
+          <a:p>
+            <a:endParaRPr lang="ru-RU"/>
+          </a:p>
+        </p:txBody>
       </p:sp>
       <p:pic>
         <p:nvPicPr>
-          <p:cNvPr id="10" name="Image 1" descr="C:\Users\Kaiba\Desktop\study\project_attack_llm\results\figures\attack_success.png">    </p:cNvPr>
+          <p:cNvPr id="10" name="Image 1" descr="C:\Users\Kaiba\Desktop\study\project_attack_llm\results\figures\attack_success.png"/>
           <p:cNvPicPr>
             <a:picLocks noChangeAspect="1"/>
           </p:cNvPicPr>
           <p:nvPr/>
         </p:nvPicPr>
         <p:blipFill>
-          <a:blip r:embed="rId2"/>
+          <a:blip r:embed="rId4"/>
           <a:stretch>
             <a:fillRect/>
           </a:stretch>
@@ -2927,7 +2734,7 @@
           <a:bodyPr wrap="square" rtlCol="0" anchor="ctr"/>
           <a:lstStyle/>
           <a:p>
-            <a:pPr algn="ctr" indent="0" marL="0">
+            <a:pPr marL="0" indent="0" algn="ctr">
               <a:buNone/>
             </a:pPr>
             <a:r>
@@ -2966,7 +2773,7 @@
           <a:bodyPr wrap="square" rtlCol="0" anchor="ctr"/>
           <a:lstStyle/>
           <a:p>
-            <a:pPr algn="ctr" indent="0" marL="0">
+            <a:pPr marL="0" indent="0" algn="ctr">
               <a:buNone/>
             </a:pPr>
             <a:r>
@@ -2980,9 +2787,6 @@
               </a:rPr>
               <a:t>Устойчивая модель превосходит базовую при всех ε; успех атаки PGD упал с </a:t>
             </a:r>
-            <a:pPr algn="ctr" indent="0" marL="0">
-              <a:buNone/>
-            </a:pPr>
             <a:r>
               <a:rPr lang="en-US" sz="1500" b="1" dirty="0">
                 <a:solidFill>
@@ -2994,9 +2798,6 @@
               </a:rPr>
               <a:t>98 % до 8 %</a:t>
             </a:r>
-            <a:pPr algn="ctr" indent="0" marL="0">
-              <a:buNone/>
-            </a:pPr>
             <a:r>
               <a:rPr lang="en-US" sz="1500" dirty="0">
                 <a:solidFill>
@@ -3028,6 +2829,7 @@
         <a:solidFill>
           <a:srgbClr val="F4F6FB"/>
         </a:solidFill>
+        <a:effectLst/>
       </p:bgPr>
     </p:bg>
     <p:spTree>
@@ -3063,6 +2865,13 @@
           </a:solidFill>
           <a:ln/>
         </p:spPr>
+        <p:txBody>
+          <a:bodyPr/>
+          <a:lstStyle/>
+          <a:p>
+            <a:endParaRPr lang="ru-RU"/>
+          </a:p>
+        </p:txBody>
       </p:sp>
       <p:sp>
         <p:nvSpPr>
@@ -3085,7 +2894,7 @@
           <a:bodyPr wrap="square" lIns="0" tIns="0" rIns="0" bIns="0" rtlCol="0" anchor="ctr"/>
           <a:lstStyle/>
           <a:p>
-            <a:pPr indent="0" marL="0">
+            <a:pPr marL="0" indent="0">
               <a:buNone/>
             </a:pPr>
             <a:r>
@@ -3124,7 +2933,7 @@
           <a:bodyPr wrap="square" rtlCol="0" anchor="ctr"/>
           <a:lstStyle/>
           <a:p>
-            <a:pPr algn="r" indent="0" marL="0">
+            <a:pPr marL="0" indent="0" algn="r">
               <a:buNone/>
             </a:pPr>
             <a:r>
@@ -3163,7 +2972,7 @@
           <a:bodyPr wrap="square" rtlCol="0" anchor="ctr"/>
           <a:lstStyle/>
           <a:p>
-            <a:pPr algn="l" indent="0" marL="0">
+            <a:pPr marL="0" indent="0" algn="l">
               <a:buNone/>
             </a:pPr>
             <a:r>
@@ -3202,7 +3011,7 @@
           <a:bodyPr wrap="square" rtlCol="0" anchor="ctr"/>
           <a:lstStyle/>
           <a:p>
-            <a:pPr indent="0" marL="0">
+            <a:pPr marL="0" indent="0">
               <a:buNone/>
             </a:pPr>
             <a:r>
@@ -3246,13 +3055,20 @@
             <a:prstDash val="solid"/>
           </a:ln>
           <a:effectLst>
-            <a:outerShdw sx="100000" sy="100000" kx="0" ky="0" algn="bl" rotWithShape="0" blurRad="114300" dist="38100" dir="5400000">
+            <a:outerShdw blurRad="114300" dist="38100" dir="5400000" algn="bl" rotWithShape="0">
               <a:srgbClr val="0A1430">
                 <a:alpha val="18000"/>
               </a:srgbClr>
             </a:outerShdw>
           </a:effectLst>
         </p:spPr>
+        <p:txBody>
+          <a:bodyPr/>
+          <a:lstStyle/>
+          <a:p>
+            <a:endParaRPr lang="ru-RU"/>
+          </a:p>
+        </p:txBody>
       </p:sp>
       <p:sp>
         <p:nvSpPr>
@@ -3273,6 +3089,13 @@
           </a:solidFill>
           <a:ln/>
         </p:spPr>
+        <p:txBody>
+          <a:bodyPr/>
+          <a:lstStyle/>
+          <a:p>
+            <a:endParaRPr lang="ru-RU"/>
+          </a:p>
+        </p:txBody>
       </p:sp>
       <p:sp>
         <p:nvSpPr>
@@ -3295,7 +3118,7 @@
           <a:bodyPr wrap="square" lIns="0" tIns="0" rIns="0" bIns="0" rtlCol="0" anchor="ctr"/>
           <a:lstStyle/>
           <a:p>
-            <a:pPr indent="0" marL="0">
+            <a:pPr marL="0" indent="0">
               <a:buNone/>
             </a:pPr>
             <a:r>
@@ -3424,13 +3247,20 @@
             <a:prstDash val="solid"/>
           </a:ln>
           <a:effectLst>
-            <a:outerShdw sx="100000" sy="100000" kx="0" ky="0" algn="bl" rotWithShape="0" blurRad="114300" dist="38100" dir="5400000">
+            <a:outerShdw blurRad="114300" dist="38100" dir="5400000" algn="bl" rotWithShape="0">
               <a:srgbClr val="0A1430">
                 <a:alpha val="18000"/>
               </a:srgbClr>
             </a:outerShdw>
           </a:effectLst>
         </p:spPr>
+        <p:txBody>
+          <a:bodyPr/>
+          <a:lstStyle/>
+          <a:p>
+            <a:endParaRPr lang="ru-RU"/>
+          </a:p>
+        </p:txBody>
       </p:sp>
       <p:sp>
         <p:nvSpPr>
@@ -3451,6 +3281,13 @@
           </a:solidFill>
           <a:ln/>
         </p:spPr>
+        <p:txBody>
+          <a:bodyPr/>
+          <a:lstStyle/>
+          <a:p>
+            <a:endParaRPr lang="ru-RU"/>
+          </a:p>
+        </p:txBody>
       </p:sp>
       <p:sp>
         <p:nvSpPr>
@@ -3473,7 +3310,7 @@
           <a:bodyPr wrap="square" lIns="0" tIns="0" rIns="0" bIns="0" rtlCol="0" anchor="ctr"/>
           <a:lstStyle/>
           <a:p>
-            <a:pPr indent="0" marL="0">
+            <a:pPr marL="0" indent="0">
               <a:buNone/>
             </a:pPr>
             <a:r>
@@ -3592,6 +3429,7 @@
         <a:solidFill>
           <a:srgbClr val="F4F6FB"/>
         </a:solidFill>
+        <a:effectLst/>
       </p:bgPr>
     </p:bg>
     <p:spTree>
@@ -3627,6 +3465,13 @@
           </a:solidFill>
           <a:ln/>
         </p:spPr>
+        <p:txBody>
+          <a:bodyPr/>
+          <a:lstStyle/>
+          <a:p>
+            <a:endParaRPr lang="ru-RU"/>
+          </a:p>
+        </p:txBody>
       </p:sp>
       <p:sp>
         <p:nvSpPr>
@@ -3649,7 +3494,7 @@
           <a:bodyPr wrap="square" lIns="0" tIns="0" rIns="0" bIns="0" rtlCol="0" anchor="ctr"/>
           <a:lstStyle/>
           <a:p>
-            <a:pPr indent="0" marL="0">
+            <a:pPr marL="0" indent="0">
               <a:buNone/>
             </a:pPr>
             <a:r>
@@ -3688,7 +3533,7 @@
           <a:bodyPr wrap="square" rtlCol="0" anchor="ctr"/>
           <a:lstStyle/>
           <a:p>
-            <a:pPr algn="r" indent="0" marL="0">
+            <a:pPr marL="0" indent="0" algn="r">
               <a:buNone/>
             </a:pPr>
             <a:r>
@@ -3727,7 +3572,7 @@
           <a:bodyPr wrap="square" rtlCol="0" anchor="ctr"/>
           <a:lstStyle/>
           <a:p>
-            <a:pPr algn="l" indent="0" marL="0">
+            <a:pPr marL="0" indent="0" algn="l">
               <a:buNone/>
             </a:pPr>
             <a:r>
@@ -3909,6 +3754,7 @@
         <a:solidFill>
           <a:srgbClr val="0E1E40"/>
         </a:solidFill>
+        <a:effectLst/>
       </p:bgPr>
     </p:bg>
     <p:spTree>
@@ -3944,6 +3790,13 @@
           </a:solidFill>
           <a:ln/>
         </p:spPr>
+        <p:txBody>
+          <a:bodyPr/>
+          <a:lstStyle/>
+          <a:p>
+            <a:endParaRPr lang="ru-RU"/>
+          </a:p>
+        </p:txBody>
       </p:sp>
       <p:sp>
         <p:nvSpPr>
@@ -3964,6 +3817,13 @@
           </a:solidFill>
           <a:ln/>
         </p:spPr>
+        <p:txBody>
+          <a:bodyPr/>
+          <a:lstStyle/>
+          <a:p>
+            <a:endParaRPr lang="ru-RU"/>
+          </a:p>
+        </p:txBody>
       </p:sp>
       <p:sp>
         <p:nvSpPr>
@@ -3986,7 +3846,7 @@
           <a:bodyPr wrap="square" rtlCol="0" anchor="ctr"/>
           <a:lstStyle/>
           <a:p>
-            <a:pPr indent="0" marL="0">
+            <a:pPr marL="0" indent="0">
               <a:buNone/>
             </a:pPr>
             <a:r>
@@ -4025,7 +3885,7 @@
           <a:bodyPr wrap="square" rtlCol="0" anchor="ctr"/>
           <a:lstStyle/>
           <a:p>
-            <a:pPr indent="0" marL="0">
+            <a:pPr marL="0" indent="0">
               <a:buNone/>
             </a:pPr>
             <a:r>
@@ -4064,7 +3924,7 @@
           <a:bodyPr wrap="square" rtlCol="0" anchor="ctr"/>
           <a:lstStyle/>
           <a:p>
-            <a:pPr indent="0" marL="0">
+            <a:pPr marL="0" indent="0">
               <a:buNone/>
             </a:pPr>
             <a:r>
@@ -4098,6 +3958,7 @@
         <a:solidFill>
           <a:srgbClr val="F4F6FB"/>
         </a:solidFill>
+        <a:effectLst/>
       </p:bgPr>
     </p:bg>
     <p:spTree>
@@ -4133,6 +3994,13 @@
           </a:solidFill>
           <a:ln/>
         </p:spPr>
+        <p:txBody>
+          <a:bodyPr/>
+          <a:lstStyle/>
+          <a:p>
+            <a:endParaRPr lang="ru-RU"/>
+          </a:p>
+        </p:txBody>
       </p:sp>
       <p:sp>
         <p:nvSpPr>
@@ -4155,7 +4023,7 @@
           <a:bodyPr wrap="square" lIns="0" tIns="0" rIns="0" bIns="0" rtlCol="0" anchor="ctr"/>
           <a:lstStyle/>
           <a:p>
-            <a:pPr indent="0" marL="0">
+            <a:pPr marL="0" indent="0">
               <a:buNone/>
             </a:pPr>
             <a:r>
@@ -4194,7 +4062,7 @@
           <a:bodyPr wrap="square" rtlCol="0" anchor="ctr"/>
           <a:lstStyle/>
           <a:p>
-            <a:pPr algn="r" indent="0" marL="0">
+            <a:pPr marL="0" indent="0" algn="r">
               <a:buNone/>
             </a:pPr>
             <a:r>
@@ -4233,7 +4101,7 @@
           <a:bodyPr wrap="square" rtlCol="0" anchor="ctr"/>
           <a:lstStyle/>
           <a:p>
-            <a:pPr algn="l" indent="0" marL="0">
+            <a:pPr marL="0" indent="0" algn="l">
               <a:buNone/>
             </a:pPr>
             <a:r>
@@ -4272,7 +4140,7 @@
           <a:bodyPr wrap="square" rtlCol="0" anchor="ctr"/>
           <a:lstStyle/>
           <a:p>
-            <a:pPr indent="0" marL="0">
+            <a:pPr marL="0" indent="0">
               <a:buNone/>
             </a:pPr>
             <a:r>
@@ -4316,13 +4184,20 @@
             <a:prstDash val="solid"/>
           </a:ln>
           <a:effectLst>
-            <a:outerShdw sx="100000" sy="100000" kx="0" ky="0" algn="bl" rotWithShape="0" blurRad="114300" dist="38100" dir="5400000">
+            <a:outerShdw blurRad="114300" dist="38100" dir="5400000" algn="bl" rotWithShape="0">
               <a:srgbClr val="0A1430">
                 <a:alpha val="18000"/>
               </a:srgbClr>
             </a:outerShdw>
           </a:effectLst>
         </p:spPr>
+        <p:txBody>
+          <a:bodyPr/>
+          <a:lstStyle/>
+          <a:p>
+            <a:endParaRPr lang="ru-RU"/>
+          </a:p>
+        </p:txBody>
       </p:sp>
       <p:sp>
         <p:nvSpPr>
@@ -4343,6 +4218,13 @@
           </a:solidFill>
           <a:ln/>
         </p:spPr>
+        <p:txBody>
+          <a:bodyPr/>
+          <a:lstStyle/>
+          <a:p>
+            <a:endParaRPr lang="ru-RU"/>
+          </a:p>
+        </p:txBody>
       </p:sp>
       <p:sp>
         <p:nvSpPr>
@@ -4363,6 +4245,13 @@
           </a:solidFill>
           <a:ln/>
         </p:spPr>
+        <p:txBody>
+          <a:bodyPr/>
+          <a:lstStyle/>
+          <a:p>
+            <a:endParaRPr lang="ru-RU"/>
+          </a:p>
+        </p:txBody>
       </p:sp>
       <p:sp>
         <p:nvSpPr>
@@ -4385,7 +4274,7 @@
           <a:bodyPr wrap="square" lIns="0" tIns="0" rIns="0" bIns="0" rtlCol="0" anchor="ctr"/>
           <a:lstStyle/>
           <a:p>
-            <a:pPr algn="ctr" indent="0" marL="0">
+            <a:pPr marL="0" indent="0" algn="ctr">
               <a:buNone/>
             </a:pPr>
             <a:r>
@@ -4424,7 +4313,7 @@
           <a:bodyPr wrap="square" lIns="0" tIns="0" rIns="0" bIns="0" rtlCol="0" anchor="ctr"/>
           <a:lstStyle/>
           <a:p>
-            <a:pPr indent="0" marL="0">
+            <a:pPr marL="0" indent="0">
               <a:buNone/>
             </a:pPr>
             <a:r>
@@ -4463,7 +4352,7 @@
           <a:bodyPr wrap="square" lIns="0" tIns="0" rIns="0" bIns="0" rtlCol="0" anchor="ctr"/>
           <a:lstStyle/>
           <a:p>
-            <a:pPr indent="0" marL="0">
+            <a:pPr marL="0" indent="0">
               <a:buNone/>
             </a:pPr>
             <a:r>
@@ -4507,13 +4396,20 @@
             <a:prstDash val="solid"/>
           </a:ln>
           <a:effectLst>
-            <a:outerShdw sx="100000" sy="100000" kx="0" ky="0" algn="bl" rotWithShape="0" blurRad="114300" dist="38100" dir="5400000">
+            <a:outerShdw blurRad="114300" dist="38100" dir="5400000" algn="bl" rotWithShape="0">
               <a:srgbClr val="0A1430">
                 <a:alpha val="18000"/>
               </a:srgbClr>
             </a:outerShdw>
           </a:effectLst>
         </p:spPr>
+        <p:txBody>
+          <a:bodyPr/>
+          <a:lstStyle/>
+          <a:p>
+            <a:endParaRPr lang="ru-RU"/>
+          </a:p>
+        </p:txBody>
       </p:sp>
       <p:sp>
         <p:nvSpPr>
@@ -4534,6 +4430,13 @@
           </a:solidFill>
           <a:ln/>
         </p:spPr>
+        <p:txBody>
+          <a:bodyPr/>
+          <a:lstStyle/>
+          <a:p>
+            <a:endParaRPr lang="ru-RU"/>
+          </a:p>
+        </p:txBody>
       </p:sp>
       <p:sp>
         <p:nvSpPr>
@@ -4554,6 +4457,13 @@
           </a:solidFill>
           <a:ln/>
         </p:spPr>
+        <p:txBody>
+          <a:bodyPr/>
+          <a:lstStyle/>
+          <a:p>
+            <a:endParaRPr lang="ru-RU"/>
+          </a:p>
+        </p:txBody>
       </p:sp>
       <p:sp>
         <p:nvSpPr>
@@ -4576,7 +4486,7 @@
           <a:bodyPr wrap="square" lIns="0" tIns="0" rIns="0" bIns="0" rtlCol="0" anchor="ctr"/>
           <a:lstStyle/>
           <a:p>
-            <a:pPr algn="ctr" indent="0" marL="0">
+            <a:pPr marL="0" indent="0" algn="ctr">
               <a:buNone/>
             </a:pPr>
             <a:r>
@@ -4615,7 +4525,7 @@
           <a:bodyPr wrap="square" lIns="0" tIns="0" rIns="0" bIns="0" rtlCol="0" anchor="ctr"/>
           <a:lstStyle/>
           <a:p>
-            <a:pPr indent="0" marL="0">
+            <a:pPr marL="0" indent="0">
               <a:buNone/>
             </a:pPr>
             <a:r>
@@ -4654,7 +4564,7 @@
           <a:bodyPr wrap="square" lIns="0" tIns="0" rIns="0" bIns="0" rtlCol="0" anchor="ctr"/>
           <a:lstStyle/>
           <a:p>
-            <a:pPr indent="0" marL="0">
+            <a:pPr marL="0" indent="0">
               <a:buNone/>
             </a:pPr>
             <a:r>
@@ -4698,13 +4608,20 @@
             <a:prstDash val="solid"/>
           </a:ln>
           <a:effectLst>
-            <a:outerShdw sx="100000" sy="100000" kx="0" ky="0" algn="bl" rotWithShape="0" blurRad="114300" dist="38100" dir="5400000">
+            <a:outerShdw blurRad="114300" dist="38100" dir="5400000" algn="bl" rotWithShape="0">
               <a:srgbClr val="0A1430">
                 <a:alpha val="18000"/>
               </a:srgbClr>
             </a:outerShdw>
           </a:effectLst>
         </p:spPr>
+        <p:txBody>
+          <a:bodyPr/>
+          <a:lstStyle/>
+          <a:p>
+            <a:endParaRPr lang="ru-RU"/>
+          </a:p>
+        </p:txBody>
       </p:sp>
       <p:sp>
         <p:nvSpPr>
@@ -4725,6 +4642,13 @@
           </a:solidFill>
           <a:ln/>
         </p:spPr>
+        <p:txBody>
+          <a:bodyPr/>
+          <a:lstStyle/>
+          <a:p>
+            <a:endParaRPr lang="ru-RU"/>
+          </a:p>
+        </p:txBody>
       </p:sp>
       <p:sp>
         <p:nvSpPr>
@@ -4745,6 +4669,13 @@
           </a:solidFill>
           <a:ln/>
         </p:spPr>
+        <p:txBody>
+          <a:bodyPr/>
+          <a:lstStyle/>
+          <a:p>
+            <a:endParaRPr lang="ru-RU"/>
+          </a:p>
+        </p:txBody>
       </p:sp>
       <p:sp>
         <p:nvSpPr>
@@ -4767,7 +4698,7 @@
           <a:bodyPr wrap="square" lIns="0" tIns="0" rIns="0" bIns="0" rtlCol="0" anchor="ctr"/>
           <a:lstStyle/>
           <a:p>
-            <a:pPr algn="ctr" indent="0" marL="0">
+            <a:pPr marL="0" indent="0" algn="ctr">
               <a:buNone/>
             </a:pPr>
             <a:r>
@@ -4806,7 +4737,7 @@
           <a:bodyPr wrap="square" lIns="0" tIns="0" rIns="0" bIns="0" rtlCol="0" anchor="ctr"/>
           <a:lstStyle/>
           <a:p>
-            <a:pPr indent="0" marL="0">
+            <a:pPr marL="0" indent="0">
               <a:buNone/>
             </a:pPr>
             <a:r>
@@ -4845,7 +4776,7 @@
           <a:bodyPr wrap="square" lIns="0" tIns="0" rIns="0" bIns="0" rtlCol="0" anchor="ctr"/>
           <a:lstStyle/>
           <a:p>
-            <a:pPr indent="0" marL="0">
+            <a:pPr marL="0" indent="0">
               <a:buNone/>
             </a:pPr>
             <a:r>
@@ -4879,6 +4810,7 @@
         <a:solidFill>
           <a:srgbClr val="F4F6FB"/>
         </a:solidFill>
+        <a:effectLst/>
       </p:bgPr>
     </p:bg>
     <p:spTree>
@@ -4914,6 +4846,13 @@
           </a:solidFill>
           <a:ln/>
         </p:spPr>
+        <p:txBody>
+          <a:bodyPr/>
+          <a:lstStyle/>
+          <a:p>
+            <a:endParaRPr lang="ru-RU"/>
+          </a:p>
+        </p:txBody>
       </p:sp>
       <p:sp>
         <p:nvSpPr>
@@ -4936,7 +4875,7 @@
           <a:bodyPr wrap="square" lIns="0" tIns="0" rIns="0" bIns="0" rtlCol="0" anchor="ctr"/>
           <a:lstStyle/>
           <a:p>
-            <a:pPr indent="0" marL="0">
+            <a:pPr marL="0" indent="0">
               <a:buNone/>
             </a:pPr>
             <a:r>
@@ -4975,7 +4914,7 @@
           <a:bodyPr wrap="square" rtlCol="0" anchor="ctr"/>
           <a:lstStyle/>
           <a:p>
-            <a:pPr algn="r" indent="0" marL="0">
+            <a:pPr marL="0" indent="0" algn="r">
               <a:buNone/>
             </a:pPr>
             <a:r>
@@ -5014,7 +4953,7 @@
           <a:bodyPr wrap="square" rtlCol="0" anchor="ctr"/>
           <a:lstStyle/>
           <a:p>
-            <a:pPr algn="l" indent="0" marL="0">
+            <a:pPr marL="0" indent="0" algn="l">
               <a:buNone/>
             </a:pPr>
             <a:r>
@@ -5058,13 +4997,20 @@
             <a:prstDash val="solid"/>
           </a:ln>
           <a:effectLst>
-            <a:outerShdw sx="100000" sy="100000" kx="0" ky="0" algn="bl" rotWithShape="0" blurRad="114300" dist="38100" dir="5400000">
+            <a:outerShdw blurRad="114300" dist="38100" dir="5400000" algn="bl" rotWithShape="0">
               <a:srgbClr val="0A1430">
                 <a:alpha val="18000"/>
               </a:srgbClr>
             </a:outerShdw>
           </a:effectLst>
         </p:spPr>
+        <p:txBody>
+          <a:bodyPr/>
+          <a:lstStyle/>
+          <a:p>
+            <a:endParaRPr lang="ru-RU"/>
+          </a:p>
+        </p:txBody>
       </p:sp>
       <p:sp>
         <p:nvSpPr>
@@ -5087,7 +5033,7 @@
           <a:bodyPr wrap="square" lIns="0" tIns="0" rIns="0" bIns="0" rtlCol="0" anchor="ctr"/>
           <a:lstStyle/>
           <a:p>
-            <a:pPr indent="0" marL="0">
+            <a:pPr marL="0" indent="0">
               <a:buNone/>
             </a:pPr>
             <a:r>
@@ -5126,7 +5072,7 @@
           <a:bodyPr wrap="square" lIns="0" tIns="0" rIns="0" bIns="0" rtlCol="0" anchor="t"/>
           <a:lstStyle/>
           <a:p>
-            <a:pPr indent="0" marL="0">
+            <a:pPr marL="0" indent="0">
               <a:lnSpc>
                 <a:spcPct val="115000"/>
               </a:lnSpc>
@@ -5168,7 +5114,7 @@
           <a:bodyPr wrap="square" rtlCol="0" anchor="ctr"/>
           <a:lstStyle/>
           <a:p>
-            <a:pPr indent="0" marL="0">
+            <a:pPr marL="0" indent="0">
               <a:buNone/>
             </a:pPr>
             <a:r>
@@ -5213,7 +5159,7 @@
               </a:spcAft>
               <a:buSzPct val="100000"/>
               <a:buFont typeface="+mj-lt"/>
-              <a:buAutoNum type="arabicPeriod" startAt="1"/>
+              <a:buAutoNum type="arabicPeriod"/>
             </a:pPr>
             <a:r>
               <a:rPr lang="en-US" sz="1600" dirty="0">
@@ -5235,7 +5181,7 @@
               </a:spcAft>
               <a:buSzPct val="100000"/>
               <a:buFont typeface="+mj-lt"/>
-              <a:buAutoNum type="arabicPeriod" startAt="1"/>
+              <a:buAutoNum type="arabicPeriod"/>
             </a:pPr>
             <a:r>
               <a:rPr lang="en-US" sz="1600" dirty="0">
@@ -5257,7 +5203,7 @@
               </a:spcAft>
               <a:buSzPct val="100000"/>
               <a:buFont typeface="+mj-lt"/>
-              <a:buAutoNum type="arabicPeriod" startAt="1"/>
+              <a:buAutoNum type="arabicPeriod"/>
             </a:pPr>
             <a:r>
               <a:rPr lang="en-US" sz="1600" dirty="0">
@@ -5279,7 +5225,7 @@
               </a:spcAft>
               <a:buSzPct val="100000"/>
               <a:buFont typeface="+mj-lt"/>
-              <a:buAutoNum type="arabicPeriod" startAt="1"/>
+              <a:buAutoNum type="arabicPeriod"/>
             </a:pPr>
             <a:r>
               <a:rPr lang="en-US" sz="1600" dirty="0">
@@ -5301,7 +5247,7 @@
               </a:spcAft>
               <a:buSzPct val="100000"/>
               <a:buFont typeface="+mj-lt"/>
-              <a:buAutoNum type="arabicPeriod" startAt="1"/>
+              <a:buAutoNum type="arabicPeriod"/>
             </a:pPr>
             <a:r>
               <a:rPr lang="en-US" sz="1600" dirty="0">
@@ -5323,7 +5269,7 @@
               </a:spcAft>
               <a:buSzPct val="100000"/>
               <a:buFont typeface="+mj-lt"/>
-              <a:buAutoNum type="arabicPeriod" startAt="1"/>
+              <a:buAutoNum type="arabicPeriod"/>
             </a:pPr>
             <a:r>
               <a:rPr lang="en-US" sz="1600" dirty="0">
@@ -5356,6 +5302,7 @@
         <a:solidFill>
           <a:srgbClr val="F4F6FB"/>
         </a:solidFill>
+        <a:effectLst/>
       </p:bgPr>
     </p:bg>
     <p:spTree>
@@ -5391,6 +5338,13 @@
           </a:solidFill>
           <a:ln/>
         </p:spPr>
+        <p:txBody>
+          <a:bodyPr/>
+          <a:lstStyle/>
+          <a:p>
+            <a:endParaRPr lang="ru-RU"/>
+          </a:p>
+        </p:txBody>
       </p:sp>
       <p:sp>
         <p:nvSpPr>
@@ -5413,7 +5367,7 @@
           <a:bodyPr wrap="square" lIns="0" tIns="0" rIns="0" bIns="0" rtlCol="0" anchor="ctr"/>
           <a:lstStyle/>
           <a:p>
-            <a:pPr indent="0" marL="0">
+            <a:pPr marL="0" indent="0">
               <a:buNone/>
             </a:pPr>
             <a:r>
@@ -5452,7 +5406,7 @@
           <a:bodyPr wrap="square" rtlCol="0" anchor="ctr"/>
           <a:lstStyle/>
           <a:p>
-            <a:pPr algn="r" indent="0" marL="0">
+            <a:pPr marL="0" indent="0" algn="r">
               <a:buNone/>
             </a:pPr>
             <a:r>
@@ -5491,7 +5445,7 @@
           <a:bodyPr wrap="square" rtlCol="0" anchor="ctr"/>
           <a:lstStyle/>
           <a:p>
-            <a:pPr algn="l" indent="0" marL="0">
+            <a:pPr marL="0" indent="0" algn="l">
               <a:buNone/>
             </a:pPr>
             <a:r>
@@ -5530,7 +5484,7 @@
           <a:bodyPr wrap="square" rtlCol="0" anchor="ctr"/>
           <a:lstStyle/>
           <a:p>
-            <a:pPr algn="ctr" indent="0" marL="0">
+            <a:pPr marL="0" indent="0" algn="ctr">
               <a:lnSpc>
                 <a:spcPct val="115000"/>
               </a:lnSpc>
@@ -5547,12 +5501,6 @@
               </a:rPr>
               <a:t>Состязательный пример</a:t>
             </a:r>
-            <a:pPr algn="ctr" indent="0" marL="0">
-              <a:lnSpc>
-                <a:spcPct val="115000"/>
-              </a:lnSpc>
-              <a:buNone/>
-            </a:pPr>
             <a:r>
               <a:rPr lang="en-US" sz="1800" dirty="0">
                 <a:solidFill>
@@ -5594,13 +5542,20 @@
             <a:prstDash val="solid"/>
           </a:ln>
           <a:effectLst>
-            <a:outerShdw sx="100000" sy="100000" kx="0" ky="0" algn="bl" rotWithShape="0" blurRad="114300" dist="38100" dir="5400000">
+            <a:outerShdw blurRad="114300" dist="38100" dir="5400000" algn="bl" rotWithShape="0">
               <a:srgbClr val="0A1430">
                 <a:alpha val="18000"/>
               </a:srgbClr>
             </a:outerShdw>
           </a:effectLst>
         </p:spPr>
+        <p:txBody>
+          <a:bodyPr/>
+          <a:lstStyle/>
+          <a:p>
+            <a:endParaRPr lang="ru-RU"/>
+          </a:p>
+        </p:txBody>
       </p:sp>
       <p:sp>
         <p:nvSpPr>
@@ -5623,7 +5578,7 @@
           <a:bodyPr wrap="square" lIns="0" tIns="0" rIns="0" bIns="0" rtlCol="0" anchor="ctr"/>
           <a:lstStyle/>
           <a:p>
-            <a:pPr algn="ctr" indent="0" marL="0">
+            <a:pPr marL="0" indent="0" algn="ctr">
               <a:buNone/>
             </a:pPr>
             <a:r>
@@ -5662,7 +5617,7 @@
           <a:bodyPr wrap="square" lIns="0" tIns="0" rIns="0" bIns="0" rtlCol="0" anchor="ctr"/>
           <a:lstStyle/>
           <a:p>
-            <a:pPr algn="ctr" indent="0" marL="0">
+            <a:pPr marL="0" indent="0" algn="ctr">
               <a:buNone/>
             </a:pPr>
             <a:r>
@@ -5701,7 +5656,7 @@
           <a:bodyPr wrap="square" rtlCol="0" anchor="ctr"/>
           <a:lstStyle/>
           <a:p>
-            <a:pPr algn="ctr" indent="0" marL="0">
+            <a:pPr marL="0" indent="0" algn="ctr">
               <a:buNone/>
             </a:pPr>
             <a:r>
@@ -5745,13 +5700,20 @@
             <a:prstDash val="solid"/>
           </a:ln>
           <a:effectLst>
-            <a:outerShdw sx="100000" sy="100000" kx="0" ky="0" algn="bl" rotWithShape="0" blurRad="114300" dist="38100" dir="5400000">
+            <a:outerShdw blurRad="114300" dist="38100" dir="5400000" algn="bl" rotWithShape="0">
               <a:srgbClr val="0A1430">
                 <a:alpha val="18000"/>
               </a:srgbClr>
             </a:outerShdw>
           </a:effectLst>
         </p:spPr>
+        <p:txBody>
+          <a:bodyPr/>
+          <a:lstStyle/>
+          <a:p>
+            <a:endParaRPr lang="ru-RU"/>
+          </a:p>
+        </p:txBody>
       </p:sp>
       <p:sp>
         <p:nvSpPr>
@@ -5774,7 +5736,7 @@
           <a:bodyPr wrap="square" lIns="0" tIns="0" rIns="0" bIns="0" rtlCol="0" anchor="ctr"/>
           <a:lstStyle/>
           <a:p>
-            <a:pPr algn="ctr" indent="0" marL="0">
+            <a:pPr marL="0" indent="0" algn="ctr">
               <a:buNone/>
             </a:pPr>
             <a:r>
@@ -5813,7 +5775,7 @@
           <a:bodyPr wrap="square" lIns="0" tIns="0" rIns="0" bIns="0" rtlCol="0" anchor="ctr"/>
           <a:lstStyle/>
           <a:p>
-            <a:pPr algn="ctr" indent="0" marL="0">
+            <a:pPr marL="0" indent="0" algn="ctr">
               <a:buNone/>
             </a:pPr>
             <a:r>
@@ -5852,7 +5814,7 @@
           <a:bodyPr wrap="square" rtlCol="0" anchor="ctr"/>
           <a:lstStyle/>
           <a:p>
-            <a:pPr algn="ctr" indent="0" marL="0">
+            <a:pPr marL="0" indent="0" algn="ctr">
               <a:buNone/>
             </a:pPr>
             <a:r>
@@ -5896,13 +5858,20 @@
             <a:prstDash val="solid"/>
           </a:ln>
           <a:effectLst>
-            <a:outerShdw sx="100000" sy="100000" kx="0" ky="0" algn="bl" rotWithShape="0" blurRad="114300" dist="38100" dir="5400000">
+            <a:outerShdw blurRad="114300" dist="38100" dir="5400000" algn="bl" rotWithShape="0">
               <a:srgbClr val="0A1430">
                 <a:alpha val="18000"/>
               </a:srgbClr>
             </a:outerShdw>
           </a:effectLst>
         </p:spPr>
+        <p:txBody>
+          <a:bodyPr/>
+          <a:lstStyle/>
+          <a:p>
+            <a:endParaRPr lang="ru-RU"/>
+          </a:p>
+        </p:txBody>
       </p:sp>
       <p:sp>
         <p:nvSpPr>
@@ -5925,7 +5894,7 @@
           <a:bodyPr wrap="square" lIns="0" tIns="0" rIns="0" bIns="0" rtlCol="0" anchor="ctr"/>
           <a:lstStyle/>
           <a:p>
-            <a:pPr algn="ctr" indent="0" marL="0">
+            <a:pPr marL="0" indent="0" algn="ctr">
               <a:buNone/>
             </a:pPr>
             <a:r>
@@ -5964,7 +5933,7 @@
           <a:bodyPr wrap="square" lIns="0" tIns="0" rIns="0" bIns="0" rtlCol="0" anchor="ctr"/>
           <a:lstStyle/>
           <a:p>
-            <a:pPr algn="ctr" indent="0" marL="0">
+            <a:pPr marL="0" indent="0" algn="ctr">
               <a:buNone/>
             </a:pPr>
             <a:r>
@@ -6003,7 +5972,7 @@
           <a:bodyPr wrap="square" rtlCol="0" anchor="ctr"/>
           <a:lstStyle/>
           <a:p>
-            <a:pPr algn="ctr" indent="0" marL="0">
+            <a:pPr marL="0" indent="0" algn="ctr">
               <a:buNone/>
             </a:pPr>
             <a:r>
@@ -6037,6 +6006,7 @@
         <a:solidFill>
           <a:srgbClr val="F4F6FB"/>
         </a:solidFill>
+        <a:effectLst/>
       </p:bgPr>
     </p:bg>
     <p:spTree>
@@ -6072,6 +6042,13 @@
           </a:solidFill>
           <a:ln/>
         </p:spPr>
+        <p:txBody>
+          <a:bodyPr/>
+          <a:lstStyle/>
+          <a:p>
+            <a:endParaRPr lang="ru-RU"/>
+          </a:p>
+        </p:txBody>
       </p:sp>
       <p:sp>
         <p:nvSpPr>
@@ -6094,7 +6071,7 @@
           <a:bodyPr wrap="square" lIns="0" tIns="0" rIns="0" bIns="0" rtlCol="0" anchor="ctr"/>
           <a:lstStyle/>
           <a:p>
-            <a:pPr indent="0" marL="0">
+            <a:pPr marL="0" indent="0">
               <a:buNone/>
             </a:pPr>
             <a:r>
@@ -6133,7 +6110,7 @@
           <a:bodyPr wrap="square" rtlCol="0" anchor="ctr"/>
           <a:lstStyle/>
           <a:p>
-            <a:pPr algn="r" indent="0" marL="0">
+            <a:pPr marL="0" indent="0" algn="r">
               <a:buNone/>
             </a:pPr>
             <a:r>
@@ -6172,7 +6149,7 @@
           <a:bodyPr wrap="square" rtlCol="0" anchor="ctr"/>
           <a:lstStyle/>
           <a:p>
-            <a:pPr algn="l" indent="0" marL="0">
+            <a:pPr marL="0" indent="0" algn="l">
               <a:buNone/>
             </a:pPr>
             <a:r>
@@ -6216,13 +6193,20 @@
             <a:prstDash val="solid"/>
           </a:ln>
           <a:effectLst>
-            <a:outerShdw sx="100000" sy="100000" kx="0" ky="0" algn="bl" rotWithShape="0" blurRad="114300" dist="38100" dir="5400000">
+            <a:outerShdw blurRad="114300" dist="38100" dir="5400000" algn="bl" rotWithShape="0">
               <a:srgbClr val="0A1430">
                 <a:alpha val="18000"/>
               </a:srgbClr>
             </a:outerShdw>
           </a:effectLst>
         </p:spPr>
+        <p:txBody>
+          <a:bodyPr/>
+          <a:lstStyle/>
+          <a:p>
+            <a:endParaRPr lang="ru-RU"/>
+          </a:p>
+        </p:txBody>
       </p:sp>
       <p:sp>
         <p:nvSpPr>
@@ -6243,6 +6227,13 @@
           </a:solidFill>
           <a:ln/>
         </p:spPr>
+        <p:txBody>
+          <a:bodyPr/>
+          <a:lstStyle/>
+          <a:p>
+            <a:endParaRPr lang="ru-RU"/>
+          </a:p>
+        </p:txBody>
       </p:sp>
       <p:sp>
         <p:nvSpPr>
@@ -6265,7 +6256,7 @@
           <a:bodyPr wrap="square" lIns="0" tIns="0" rIns="0" bIns="0" rtlCol="0" anchor="ctr"/>
           <a:lstStyle/>
           <a:p>
-            <a:pPr indent="0" marL="0">
+            <a:pPr marL="0" indent="0">
               <a:buNone/>
             </a:pPr>
             <a:r>
@@ -6304,7 +6295,7 @@
           <a:bodyPr wrap="square" lIns="0" tIns="0" rIns="0" bIns="0" rtlCol="0" anchor="ctr"/>
           <a:lstStyle/>
           <a:p>
-            <a:pPr indent="0" marL="0">
+            <a:pPr marL="0" indent="0">
               <a:buNone/>
             </a:pPr>
             <a:r>
@@ -6433,13 +6424,20 @@
             <a:prstDash val="solid"/>
           </a:ln>
           <a:effectLst>
-            <a:outerShdw sx="100000" sy="100000" kx="0" ky="0" algn="bl" rotWithShape="0" blurRad="114300" dist="38100" dir="5400000">
+            <a:outerShdw blurRad="114300" dist="38100" dir="5400000" algn="bl" rotWithShape="0">
               <a:srgbClr val="0A1430">
                 <a:alpha val="18000"/>
               </a:srgbClr>
             </a:outerShdw>
           </a:effectLst>
         </p:spPr>
+        <p:txBody>
+          <a:bodyPr/>
+          <a:lstStyle/>
+          <a:p>
+            <a:endParaRPr lang="ru-RU"/>
+          </a:p>
+        </p:txBody>
       </p:sp>
       <p:sp>
         <p:nvSpPr>
@@ -6460,6 +6458,13 @@
           </a:solidFill>
           <a:ln/>
         </p:spPr>
+        <p:txBody>
+          <a:bodyPr/>
+          <a:lstStyle/>
+          <a:p>
+            <a:endParaRPr lang="ru-RU"/>
+          </a:p>
+        </p:txBody>
       </p:sp>
       <p:sp>
         <p:nvSpPr>
@@ -6482,7 +6487,7 @@
           <a:bodyPr wrap="square" lIns="0" tIns="0" rIns="0" bIns="0" rtlCol="0" anchor="ctr"/>
           <a:lstStyle/>
           <a:p>
-            <a:pPr indent="0" marL="0">
+            <a:pPr marL="0" indent="0">
               <a:buNone/>
             </a:pPr>
             <a:r>
@@ -6521,7 +6526,7 @@
           <a:bodyPr wrap="square" lIns="0" tIns="0" rIns="0" bIns="0" rtlCol="0" anchor="ctr"/>
           <a:lstStyle/>
           <a:p>
-            <a:pPr indent="0" marL="0">
+            <a:pPr marL="0" indent="0">
               <a:buNone/>
             </a:pPr>
             <a:r>
@@ -6640,6 +6645,7 @@
         <a:solidFill>
           <a:srgbClr val="F4F6FB"/>
         </a:solidFill>
+        <a:effectLst/>
       </p:bgPr>
     </p:bg>
     <p:spTree>
@@ -6675,6 +6681,13 @@
           </a:solidFill>
           <a:ln/>
         </p:spPr>
+        <p:txBody>
+          <a:bodyPr/>
+          <a:lstStyle/>
+          <a:p>
+            <a:endParaRPr lang="ru-RU"/>
+          </a:p>
+        </p:txBody>
       </p:sp>
       <p:sp>
         <p:nvSpPr>
@@ -6697,7 +6710,7 @@
           <a:bodyPr wrap="square" lIns="0" tIns="0" rIns="0" bIns="0" rtlCol="0" anchor="ctr"/>
           <a:lstStyle/>
           <a:p>
-            <a:pPr indent="0" marL="0">
+            <a:pPr marL="0" indent="0">
               <a:buNone/>
             </a:pPr>
             <a:r>
@@ -6736,7 +6749,7 @@
           <a:bodyPr wrap="square" rtlCol="0" anchor="ctr"/>
           <a:lstStyle/>
           <a:p>
-            <a:pPr algn="r" indent="0" marL="0">
+            <a:pPr marL="0" indent="0" algn="r">
               <a:buNone/>
             </a:pPr>
             <a:r>
@@ -6775,7 +6788,7 @@
           <a:bodyPr wrap="square" rtlCol="0" anchor="ctr"/>
           <a:lstStyle/>
           <a:p>
-            <a:pPr algn="l" indent="0" marL="0">
+            <a:pPr marL="0" indent="0" algn="l">
               <a:buNone/>
             </a:pPr>
             <a:r>
@@ -6814,7 +6827,7 @@
           <a:bodyPr wrap="square" rtlCol="0" anchor="ctr"/>
           <a:lstStyle/>
           <a:p>
-            <a:pPr indent="0" marL="0">
+            <a:pPr marL="0" indent="0">
               <a:buNone/>
             </a:pPr>
             <a:r>
@@ -6828,9 +6841,6 @@
               </a:rPr>
               <a:t>Состязательное обучение</a:t>
             </a:r>
-            <a:pPr indent="0" marL="0">
-              <a:buNone/>
-            </a:pPr>
             <a:r>
               <a:rPr lang="en-US" sz="1700" dirty="0">
                 <a:solidFill>
@@ -6872,13 +6882,20 @@
             <a:prstDash val="solid"/>
           </a:ln>
           <a:effectLst>
-            <a:outerShdw sx="100000" sy="100000" kx="0" ky="0" algn="bl" rotWithShape="0" blurRad="114300" dist="38100" dir="5400000">
+            <a:outerShdw blurRad="114300" dist="38100" dir="5400000" algn="bl" rotWithShape="0">
               <a:srgbClr val="0A1430">
                 <a:alpha val="18000"/>
               </a:srgbClr>
             </a:outerShdw>
           </a:effectLst>
         </p:spPr>
+        <p:txBody>
+          <a:bodyPr/>
+          <a:lstStyle/>
+          <a:p>
+            <a:endParaRPr lang="ru-RU"/>
+          </a:p>
+        </p:txBody>
       </p:sp>
       <p:sp>
         <p:nvSpPr>
@@ -6901,7 +6918,7 @@
           <a:bodyPr wrap="square" rtlCol="0" anchor="ctr"/>
           <a:lstStyle/>
           <a:p>
-            <a:pPr algn="ctr" indent="0" marL="0">
+            <a:pPr marL="0" indent="0" algn="ctr">
               <a:buNone/>
             </a:pPr>
             <a:r>
@@ -6945,13 +6962,20 @@
             <a:prstDash val="solid"/>
           </a:ln>
           <a:effectLst>
-            <a:outerShdw sx="100000" sy="100000" kx="0" ky="0" algn="bl" rotWithShape="0" blurRad="114300" dist="38100" dir="5400000">
+            <a:outerShdw blurRad="114300" dist="38100" dir="5400000" algn="bl" rotWithShape="0">
               <a:srgbClr val="0A1430">
                 <a:alpha val="18000"/>
               </a:srgbClr>
             </a:outerShdw>
           </a:effectLst>
         </p:spPr>
+        <p:txBody>
+          <a:bodyPr/>
+          <a:lstStyle/>
+          <a:p>
+            <a:endParaRPr lang="ru-RU"/>
+          </a:p>
+        </p:txBody>
       </p:sp>
       <p:sp>
         <p:nvSpPr>
@@ -6972,6 +6996,13 @@
           </a:solidFill>
           <a:ln/>
         </p:spPr>
+        <p:txBody>
+          <a:bodyPr/>
+          <a:lstStyle/>
+          <a:p>
+            <a:endParaRPr lang="ru-RU"/>
+          </a:p>
+        </p:txBody>
       </p:sp>
       <p:sp>
         <p:nvSpPr>
@@ -6994,7 +7025,7 @@
           <a:bodyPr wrap="square" lIns="0" tIns="0" rIns="0" bIns="0" rtlCol="0" anchor="ctr"/>
           <a:lstStyle/>
           <a:p>
-            <a:pPr indent="0" marL="0">
+            <a:pPr marL="0" indent="0">
               <a:buNone/>
             </a:pPr>
             <a:r>
@@ -7033,7 +7064,7 @@
           <a:bodyPr wrap="square" lIns="0" tIns="0" rIns="0" bIns="0" rtlCol="0" anchor="ctr"/>
           <a:lstStyle/>
           <a:p>
-            <a:pPr indent="0" marL="0">
+            <a:pPr marL="0" indent="0">
               <a:buNone/>
             </a:pPr>
             <a:r>
@@ -7077,13 +7108,20 @@
             <a:prstDash val="solid"/>
           </a:ln>
           <a:effectLst>
-            <a:outerShdw sx="100000" sy="100000" kx="0" ky="0" algn="bl" rotWithShape="0" blurRad="114300" dist="38100" dir="5400000">
+            <a:outerShdw blurRad="114300" dist="38100" dir="5400000" algn="bl" rotWithShape="0">
               <a:srgbClr val="0A1430">
                 <a:alpha val="18000"/>
               </a:srgbClr>
             </a:outerShdw>
           </a:effectLst>
         </p:spPr>
+        <p:txBody>
+          <a:bodyPr/>
+          <a:lstStyle/>
+          <a:p>
+            <a:endParaRPr lang="ru-RU"/>
+          </a:p>
+        </p:txBody>
       </p:sp>
       <p:sp>
         <p:nvSpPr>
@@ -7104,6 +7142,13 @@
           </a:solidFill>
           <a:ln/>
         </p:spPr>
+        <p:txBody>
+          <a:bodyPr/>
+          <a:lstStyle/>
+          <a:p>
+            <a:endParaRPr lang="ru-RU"/>
+          </a:p>
+        </p:txBody>
       </p:sp>
       <p:sp>
         <p:nvSpPr>
@@ -7126,7 +7171,7 @@
           <a:bodyPr wrap="square" lIns="0" tIns="0" rIns="0" bIns="0" rtlCol="0" anchor="ctr"/>
           <a:lstStyle/>
           <a:p>
-            <a:pPr indent="0" marL="0">
+            <a:pPr marL="0" indent="0">
               <a:buNone/>
             </a:pPr>
             <a:r>
@@ -7165,7 +7210,7 @@
           <a:bodyPr wrap="square" lIns="0" tIns="0" rIns="0" bIns="0" rtlCol="0" anchor="ctr"/>
           <a:lstStyle/>
           <a:p>
-            <a:pPr indent="0" marL="0">
+            <a:pPr marL="0" indent="0">
               <a:buNone/>
             </a:pPr>
             <a:r>
@@ -7209,13 +7254,20 @@
             <a:prstDash val="solid"/>
           </a:ln>
           <a:effectLst>
-            <a:outerShdw sx="100000" sy="100000" kx="0" ky="0" algn="bl" rotWithShape="0" blurRad="114300" dist="38100" dir="5400000">
+            <a:outerShdw blurRad="114300" dist="38100" dir="5400000" algn="bl" rotWithShape="0">
               <a:srgbClr val="0A1430">
                 <a:alpha val="18000"/>
               </a:srgbClr>
             </a:outerShdw>
           </a:effectLst>
         </p:spPr>
+        <p:txBody>
+          <a:bodyPr/>
+          <a:lstStyle/>
+          <a:p>
+            <a:endParaRPr lang="ru-RU"/>
+          </a:p>
+        </p:txBody>
       </p:sp>
       <p:sp>
         <p:nvSpPr>
@@ -7236,6 +7288,13 @@
           </a:solidFill>
           <a:ln/>
         </p:spPr>
+        <p:txBody>
+          <a:bodyPr/>
+          <a:lstStyle/>
+          <a:p>
+            <a:endParaRPr lang="ru-RU"/>
+          </a:p>
+        </p:txBody>
       </p:sp>
       <p:sp>
         <p:nvSpPr>
@@ -7258,7 +7317,7 @@
           <a:bodyPr wrap="square" lIns="0" tIns="0" rIns="0" bIns="0" rtlCol="0" anchor="ctr"/>
           <a:lstStyle/>
           <a:p>
-            <a:pPr indent="0" marL="0">
+            <a:pPr marL="0" indent="0">
               <a:buNone/>
             </a:pPr>
             <a:r>
@@ -7297,7 +7356,7 @@
           <a:bodyPr wrap="square" lIns="0" tIns="0" rIns="0" bIns="0" rtlCol="0" anchor="ctr"/>
           <a:lstStyle/>
           <a:p>
-            <a:pPr indent="0" marL="0">
+            <a:pPr marL="0" indent="0">
               <a:buNone/>
             </a:pPr>
             <a:r>
@@ -7331,6 +7390,7 @@
         <a:solidFill>
           <a:srgbClr val="F4F6FB"/>
         </a:solidFill>
+        <a:effectLst/>
       </p:bgPr>
     </p:bg>
     <p:spTree>
@@ -7366,6 +7426,13 @@
           </a:solidFill>
           <a:ln/>
         </p:spPr>
+        <p:txBody>
+          <a:bodyPr/>
+          <a:lstStyle/>
+          <a:p>
+            <a:endParaRPr lang="ru-RU"/>
+          </a:p>
+        </p:txBody>
       </p:sp>
       <p:sp>
         <p:nvSpPr>
@@ -7388,7 +7455,7 @@
           <a:bodyPr wrap="square" lIns="0" tIns="0" rIns="0" bIns="0" rtlCol="0" anchor="ctr"/>
           <a:lstStyle/>
           <a:p>
-            <a:pPr indent="0" marL="0">
+            <a:pPr marL="0" indent="0">
               <a:buNone/>
             </a:pPr>
             <a:r>
@@ -7427,7 +7494,7 @@
           <a:bodyPr wrap="square" rtlCol="0" anchor="ctr"/>
           <a:lstStyle/>
           <a:p>
-            <a:pPr algn="r" indent="0" marL="0">
+            <a:pPr marL="0" indent="0" algn="r">
               <a:buNone/>
             </a:pPr>
             <a:r>
@@ -7466,7 +7533,7 @@
           <a:bodyPr wrap="square" rtlCol="0" anchor="ctr"/>
           <a:lstStyle/>
           <a:p>
-            <a:pPr algn="l" indent="0" marL="0">
+            <a:pPr marL="0" indent="0" algn="l">
               <a:buNone/>
             </a:pPr>
             <a:r>
@@ -7510,13 +7577,20 @@
             <a:prstDash val="solid"/>
           </a:ln>
           <a:effectLst>
-            <a:outerShdw sx="100000" sy="100000" kx="0" ky="0" algn="bl" rotWithShape="0" blurRad="114300" dist="38100" dir="5400000">
+            <a:outerShdw blurRad="114300" dist="38100" dir="5400000" algn="bl" rotWithShape="0">
               <a:srgbClr val="0A1430">
                 <a:alpha val="18000"/>
               </a:srgbClr>
             </a:outerShdw>
           </a:effectLst>
         </p:spPr>
+        <p:txBody>
+          <a:bodyPr/>
+          <a:lstStyle/>
+          <a:p>
+            <a:endParaRPr lang="ru-RU"/>
+          </a:p>
+        </p:txBody>
       </p:sp>
       <p:sp>
         <p:nvSpPr>
@@ -7539,7 +7613,7 @@
           <a:bodyPr wrap="square" lIns="0" tIns="0" rIns="0" bIns="0" rtlCol="0" anchor="ctr"/>
           <a:lstStyle/>
           <a:p>
-            <a:pPr indent="0" marL="0">
+            <a:pPr marL="0" indent="0">
               <a:buNone/>
             </a:pPr>
             <a:r>
@@ -7689,13 +7763,20 @@
             <a:prstDash val="solid"/>
           </a:ln>
           <a:effectLst>
-            <a:outerShdw sx="100000" sy="100000" kx="0" ky="0" algn="bl" rotWithShape="0" blurRad="114300" dist="38100" dir="5400000">
+            <a:outerShdw blurRad="114300" dist="38100" dir="5400000" algn="bl" rotWithShape="0">
               <a:srgbClr val="0A1430">
                 <a:alpha val="18000"/>
               </a:srgbClr>
             </a:outerShdw>
           </a:effectLst>
         </p:spPr>
+        <p:txBody>
+          <a:bodyPr/>
+          <a:lstStyle/>
+          <a:p>
+            <a:endParaRPr lang="ru-RU"/>
+          </a:p>
+        </p:txBody>
       </p:sp>
       <p:sp>
         <p:nvSpPr>
@@ -7718,7 +7799,7 @@
           <a:bodyPr wrap="square" lIns="0" tIns="0" rIns="0" bIns="0" rtlCol="0" anchor="ctr"/>
           <a:lstStyle/>
           <a:p>
-            <a:pPr indent="0" marL="0">
+            <a:pPr marL="0" indent="0">
               <a:buNone/>
             </a:pPr>
             <a:r>
@@ -7757,6 +7838,13 @@
           </a:solidFill>
           <a:ln/>
         </p:spPr>
+        <p:txBody>
+          <a:bodyPr/>
+          <a:lstStyle/>
+          <a:p>
+            <a:endParaRPr lang="ru-RU"/>
+          </a:p>
+        </p:txBody>
       </p:sp>
       <p:sp>
         <p:nvSpPr>
@@ -7779,7 +7867,7 @@
           <a:bodyPr wrap="square" lIns="0" tIns="0" rIns="0" bIns="0" rtlCol="0" anchor="ctr"/>
           <a:lstStyle/>
           <a:p>
-            <a:pPr indent="0" marL="0">
+            <a:pPr marL="0" indent="0">
               <a:buNone/>
             </a:pPr>
             <a:r>
@@ -7818,6 +7906,13 @@
           </a:solidFill>
           <a:ln/>
         </p:spPr>
+        <p:txBody>
+          <a:bodyPr/>
+          <a:lstStyle/>
+          <a:p>
+            <a:endParaRPr lang="ru-RU"/>
+          </a:p>
+        </p:txBody>
       </p:sp>
       <p:sp>
         <p:nvSpPr>
@@ -7840,7 +7935,7 @@
           <a:bodyPr wrap="square" lIns="0" tIns="0" rIns="0" bIns="0" rtlCol="0" anchor="ctr"/>
           <a:lstStyle/>
           <a:p>
-            <a:pPr indent="0" marL="0">
+            <a:pPr marL="0" indent="0">
               <a:buNone/>
             </a:pPr>
             <a:r>
@@ -7879,6 +7974,13 @@
           </a:solidFill>
           <a:ln/>
         </p:spPr>
+        <p:txBody>
+          <a:bodyPr/>
+          <a:lstStyle/>
+          <a:p>
+            <a:endParaRPr lang="ru-RU"/>
+          </a:p>
+        </p:txBody>
       </p:sp>
       <p:sp>
         <p:nvSpPr>
@@ -7901,7 +8003,7 @@
           <a:bodyPr wrap="square" lIns="0" tIns="0" rIns="0" bIns="0" rtlCol="0" anchor="ctr"/>
           <a:lstStyle/>
           <a:p>
-            <a:pPr indent="0" marL="0">
+            <a:pPr marL="0" indent="0">
               <a:buNone/>
             </a:pPr>
             <a:r>
@@ -7940,6 +8042,13 @@
           </a:solidFill>
           <a:ln/>
         </p:spPr>
+        <p:txBody>
+          <a:bodyPr/>
+          <a:lstStyle/>
+          <a:p>
+            <a:endParaRPr lang="ru-RU"/>
+          </a:p>
+        </p:txBody>
       </p:sp>
       <p:sp>
         <p:nvSpPr>
@@ -7962,7 +8071,7 @@
           <a:bodyPr wrap="square" lIns="0" tIns="0" rIns="0" bIns="0" rtlCol="0" anchor="ctr"/>
           <a:lstStyle/>
           <a:p>
-            <a:pPr indent="0" marL="0">
+            <a:pPr marL="0" indent="0">
               <a:buNone/>
             </a:pPr>
             <a:r>
@@ -8001,6 +8110,13 @@
           </a:solidFill>
           <a:ln/>
         </p:spPr>
+        <p:txBody>
+          <a:bodyPr/>
+          <a:lstStyle/>
+          <a:p>
+            <a:endParaRPr lang="ru-RU"/>
+          </a:p>
+        </p:txBody>
       </p:sp>
       <p:sp>
         <p:nvSpPr>
@@ -8023,7 +8139,7 @@
           <a:bodyPr wrap="square" lIns="0" tIns="0" rIns="0" bIns="0" rtlCol="0" anchor="ctr"/>
           <a:lstStyle/>
           <a:p>
-            <a:pPr indent="0" marL="0">
+            <a:pPr marL="0" indent="0">
               <a:buNone/>
             </a:pPr>
             <a:r>
@@ -8062,6 +8178,13 @@
           </a:solidFill>
           <a:ln/>
         </p:spPr>
+        <p:txBody>
+          <a:bodyPr/>
+          <a:lstStyle/>
+          <a:p>
+            <a:endParaRPr lang="ru-RU"/>
+          </a:p>
+        </p:txBody>
       </p:sp>
       <p:sp>
         <p:nvSpPr>
@@ -8084,7 +8207,7 @@
           <a:bodyPr wrap="square" lIns="0" tIns="0" rIns="0" bIns="0" rtlCol="0" anchor="ctr"/>
           <a:lstStyle/>
           <a:p>
-            <a:pPr indent="0" marL="0">
+            <a:pPr marL="0" indent="0">
               <a:buNone/>
             </a:pPr>
             <a:r>
@@ -8123,7 +8246,7 @@
           <a:bodyPr wrap="square" lIns="0" tIns="0" rIns="0" bIns="0" rtlCol="0" anchor="ctr"/>
           <a:lstStyle/>
           <a:p>
-            <a:pPr indent="0" marL="0">
+            <a:pPr marL="0" indent="0">
               <a:buNone/>
             </a:pPr>
             <a:r>
@@ -8157,6 +8280,7 @@
         <a:solidFill>
           <a:srgbClr val="F4F6FB"/>
         </a:solidFill>
+        <a:effectLst/>
       </p:bgPr>
     </p:bg>
     <p:spTree>
@@ -8192,6 +8316,13 @@
           </a:solidFill>
           <a:ln/>
         </p:spPr>
+        <p:txBody>
+          <a:bodyPr/>
+          <a:lstStyle/>
+          <a:p>
+            <a:endParaRPr lang="ru-RU"/>
+          </a:p>
+        </p:txBody>
       </p:sp>
       <p:sp>
         <p:nvSpPr>
@@ -8214,7 +8345,7 @@
           <a:bodyPr wrap="square" lIns="0" tIns="0" rIns="0" bIns="0" rtlCol="0" anchor="ctr"/>
           <a:lstStyle/>
           <a:p>
-            <a:pPr indent="0" marL="0">
+            <a:pPr marL="0" indent="0">
               <a:buNone/>
             </a:pPr>
             <a:r>
@@ -8253,7 +8384,7 @@
           <a:bodyPr wrap="square" rtlCol="0" anchor="ctr"/>
           <a:lstStyle/>
           <a:p>
-            <a:pPr algn="r" indent="0" marL="0">
+            <a:pPr marL="0" indent="0" algn="r">
               <a:buNone/>
             </a:pPr>
             <a:r>
@@ -8292,7 +8423,7 @@
           <a:bodyPr wrap="square" rtlCol="0" anchor="ctr"/>
           <a:lstStyle/>
           <a:p>
-            <a:pPr algn="l" indent="0" marL="0">
+            <a:pPr marL="0" indent="0" algn="l">
               <a:buNone/>
             </a:pPr>
             <a:r>
@@ -8336,13 +8467,20 @@
             <a:prstDash val="solid"/>
           </a:ln>
           <a:effectLst>
-            <a:outerShdw sx="100000" sy="100000" kx="0" ky="0" algn="bl" rotWithShape="0" blurRad="114300" dist="38100" dir="5400000">
+            <a:outerShdw blurRad="114300" dist="38100" dir="5400000" algn="bl" rotWithShape="0">
               <a:srgbClr val="0A1430">
                 <a:alpha val="18000"/>
               </a:srgbClr>
             </a:outerShdw>
           </a:effectLst>
         </p:spPr>
+        <p:txBody>
+          <a:bodyPr/>
+          <a:lstStyle/>
+          <a:p>
+            <a:endParaRPr lang="ru-RU"/>
+          </a:p>
+        </p:txBody>
       </p:sp>
       <p:sp>
         <p:nvSpPr>
@@ -8363,6 +8501,13 @@
           </a:solidFill>
           <a:ln/>
         </p:spPr>
+        <p:txBody>
+          <a:bodyPr/>
+          <a:lstStyle/>
+          <a:p>
+            <a:endParaRPr lang="ru-RU"/>
+          </a:p>
+        </p:txBody>
       </p:sp>
       <p:sp>
         <p:nvSpPr>
@@ -8385,7 +8530,7 @@
           <a:bodyPr wrap="square" lIns="0" tIns="0" rIns="0" bIns="0" rtlCol="0" anchor="ctr"/>
           <a:lstStyle/>
           <a:p>
-            <a:pPr algn="ctr" indent="0" marL="0">
+            <a:pPr marL="0" indent="0" algn="ctr">
               <a:buNone/>
             </a:pPr>
             <a:r>
@@ -8424,7 +8569,7 @@
           <a:bodyPr wrap="square" lIns="0" tIns="0" rIns="0" bIns="0" rtlCol="0" anchor="ctr"/>
           <a:lstStyle/>
           <a:p>
-            <a:pPr algn="ctr" indent="0" marL="0">
+            <a:pPr marL="0" indent="0" algn="ctr">
               <a:buNone/>
             </a:pPr>
             <a:r>
@@ -8463,7 +8608,7 @@
           <a:bodyPr wrap="square" rtlCol="0" anchor="ctr"/>
           <a:lstStyle/>
           <a:p>
-            <a:pPr algn="ctr" indent="0" marL="0">
+            <a:pPr marL="0" indent="0" algn="ctr">
               <a:buNone/>
             </a:pPr>
             <a:r>
@@ -8507,13 +8652,20 @@
             <a:prstDash val="solid"/>
           </a:ln>
           <a:effectLst>
-            <a:outerShdw sx="100000" sy="100000" kx="0" ky="0" algn="bl" rotWithShape="0" blurRad="114300" dist="38100" dir="5400000">
+            <a:outerShdw blurRad="114300" dist="38100" dir="5400000" algn="bl" rotWithShape="0">
               <a:srgbClr val="0A1430">
                 <a:alpha val="18000"/>
               </a:srgbClr>
             </a:outerShdw>
           </a:effectLst>
         </p:spPr>
+        <p:txBody>
+          <a:bodyPr/>
+          <a:lstStyle/>
+          <a:p>
+            <a:endParaRPr lang="ru-RU"/>
+          </a:p>
+        </p:txBody>
       </p:sp>
       <p:sp>
         <p:nvSpPr>
@@ -8534,6 +8686,13 @@
           </a:solidFill>
           <a:ln/>
         </p:spPr>
+        <p:txBody>
+          <a:bodyPr/>
+          <a:lstStyle/>
+          <a:p>
+            <a:endParaRPr lang="ru-RU"/>
+          </a:p>
+        </p:txBody>
       </p:sp>
       <p:sp>
         <p:nvSpPr>
@@ -8556,7 +8715,7 @@
           <a:bodyPr wrap="square" lIns="0" tIns="0" rIns="0" bIns="0" rtlCol="0" anchor="ctr"/>
           <a:lstStyle/>
           <a:p>
-            <a:pPr algn="ctr" indent="0" marL="0">
+            <a:pPr marL="0" indent="0" algn="ctr">
               <a:buNone/>
             </a:pPr>
             <a:r>
@@ -8595,7 +8754,7 @@
           <a:bodyPr wrap="square" lIns="0" tIns="0" rIns="0" bIns="0" rtlCol="0" anchor="ctr"/>
           <a:lstStyle/>
           <a:p>
-            <a:pPr algn="ctr" indent="0" marL="0">
+            <a:pPr marL="0" indent="0" algn="ctr">
               <a:buNone/>
             </a:pPr>
             <a:r>
@@ -8634,7 +8793,7 @@
           <a:bodyPr wrap="square" rtlCol="0" anchor="ctr"/>
           <a:lstStyle/>
           <a:p>
-            <a:pPr algn="ctr" indent="0" marL="0">
+            <a:pPr marL="0" indent="0" algn="ctr">
               <a:buNone/>
             </a:pPr>
             <a:r>
@@ -8678,13 +8837,20 @@
             <a:prstDash val="solid"/>
           </a:ln>
           <a:effectLst>
-            <a:outerShdw sx="100000" sy="100000" kx="0" ky="0" algn="bl" rotWithShape="0" blurRad="114300" dist="38100" dir="5400000">
+            <a:outerShdw blurRad="114300" dist="38100" dir="5400000" algn="bl" rotWithShape="0">
               <a:srgbClr val="0A1430">
                 <a:alpha val="18000"/>
               </a:srgbClr>
             </a:outerShdw>
           </a:effectLst>
         </p:spPr>
+        <p:txBody>
+          <a:bodyPr/>
+          <a:lstStyle/>
+          <a:p>
+            <a:endParaRPr lang="ru-RU"/>
+          </a:p>
+        </p:txBody>
       </p:sp>
       <p:sp>
         <p:nvSpPr>
@@ -8705,6 +8871,13 @@
           </a:solidFill>
           <a:ln/>
         </p:spPr>
+        <p:txBody>
+          <a:bodyPr/>
+          <a:lstStyle/>
+          <a:p>
+            <a:endParaRPr lang="ru-RU"/>
+          </a:p>
+        </p:txBody>
       </p:sp>
       <p:sp>
         <p:nvSpPr>
@@ -8727,7 +8900,7 @@
           <a:bodyPr wrap="square" lIns="0" tIns="0" rIns="0" bIns="0" rtlCol="0" anchor="ctr"/>
           <a:lstStyle/>
           <a:p>
-            <a:pPr algn="ctr" indent="0" marL="0">
+            <a:pPr marL="0" indent="0" algn="ctr">
               <a:buNone/>
             </a:pPr>
             <a:r>
@@ -8766,7 +8939,7 @@
           <a:bodyPr wrap="square" lIns="0" tIns="0" rIns="0" bIns="0" rtlCol="0" anchor="ctr"/>
           <a:lstStyle/>
           <a:p>
-            <a:pPr algn="ctr" indent="0" marL="0">
+            <a:pPr marL="0" indent="0" algn="ctr">
               <a:buNone/>
             </a:pPr>
             <a:r>
@@ -8805,13 +8978,20 @@
           </a:solidFill>
           <a:ln/>
           <a:effectLst>
-            <a:outerShdw sx="100000" sy="100000" kx="0" ky="0" algn="bl" rotWithShape="0" blurRad="114300" dist="38100" dir="5400000">
+            <a:outerShdw blurRad="114300" dist="38100" dir="5400000" algn="bl" rotWithShape="0">
               <a:srgbClr val="0A1430">
                 <a:alpha val="18000"/>
               </a:srgbClr>
             </a:outerShdw>
           </a:effectLst>
         </p:spPr>
+        <p:txBody>
+          <a:bodyPr/>
+          <a:lstStyle/>
+          <a:p>
+            <a:endParaRPr lang="ru-RU"/>
+          </a:p>
+        </p:txBody>
       </p:sp>
       <p:sp>
         <p:nvSpPr>
@@ -8834,7 +9014,7 @@
           <a:bodyPr wrap="square" rtlCol="0" anchor="ctr"/>
           <a:lstStyle/>
           <a:p>
-            <a:pPr indent="0" marL="0">
+            <a:pPr marL="0" indent="0">
               <a:buNone/>
             </a:pPr>
             <a:r>
@@ -8848,9 +9028,6 @@
               </a:rPr>
               <a:t>↻  Повторяется 10 итераций. </a:t>
             </a:r>
-            <a:pPr indent="0" marL="0">
-              <a:buNone/>
-            </a:pPr>
             <a:r>
               <a:rPr lang="en-US" sz="1600" dirty="0">
                 <a:solidFill>
@@ -8862,9 +9039,6 @@
               </a:rPr>
               <a:t>Оценка — фиксированной атакой PGD. Устойчивость растёт </a:t>
             </a:r>
-            <a:pPr indent="0" marL="0">
-              <a:buNone/>
-            </a:pPr>
             <a:r>
               <a:rPr lang="en-US" sz="1600" b="1" dirty="0">
                 <a:solidFill>
@@ -8876,9 +9050,6 @@
               </a:rPr>
               <a:t>2 % → 92 %</a:t>
             </a:r>
-            <a:pPr indent="0" marL="0">
-              <a:buNone/>
-            </a:pPr>
             <a:r>
               <a:rPr lang="en-US" sz="1600" dirty="0">
                 <a:solidFill>
@@ -8915,7 +9086,7 @@
           <a:bodyPr wrap="square" rtlCol="0" anchor="ctr"/>
           <a:lstStyle/>
           <a:p>
-            <a:pPr indent="0" marL="0">
+            <a:pPr marL="0" indent="0">
               <a:buNone/>
             </a:pPr>
             <a:r>
@@ -8949,6 +9120,7 @@
         <a:solidFill>
           <a:srgbClr val="F4F6FB"/>
         </a:solidFill>
+        <a:effectLst/>
       </p:bgPr>
     </p:bg>
     <p:spTree>
@@ -8984,6 +9156,13 @@
           </a:solidFill>
           <a:ln/>
         </p:spPr>
+        <p:txBody>
+          <a:bodyPr/>
+          <a:lstStyle/>
+          <a:p>
+            <a:endParaRPr lang="ru-RU"/>
+          </a:p>
+        </p:txBody>
       </p:sp>
       <p:sp>
         <p:nvSpPr>
@@ -9006,7 +9185,7 @@
           <a:bodyPr wrap="square" lIns="0" tIns="0" rIns="0" bIns="0" rtlCol="0" anchor="ctr"/>
           <a:lstStyle/>
           <a:p>
-            <a:pPr indent="0" marL="0">
+            <a:pPr marL="0" indent="0">
               <a:buNone/>
             </a:pPr>
             <a:r>
@@ -9045,7 +9224,7 @@
           <a:bodyPr wrap="square" rtlCol="0" anchor="ctr"/>
           <a:lstStyle/>
           <a:p>
-            <a:pPr algn="r" indent="0" marL="0">
+            <a:pPr marL="0" indent="0" algn="r">
               <a:buNone/>
             </a:pPr>
             <a:r>
@@ -9084,7 +9263,7 @@
           <a:bodyPr wrap="square" rtlCol="0" anchor="ctr"/>
           <a:lstStyle/>
           <a:p>
-            <a:pPr algn="l" indent="0" marL="0">
+            <a:pPr marL="0" indent="0" algn="l">
               <a:buNone/>
             </a:pPr>
             <a:r>
@@ -9123,7 +9302,7 @@
           <a:bodyPr wrap="square" lIns="0" tIns="0" rIns="0" bIns="0" rtlCol="0" anchor="ctr"/>
           <a:lstStyle/>
           <a:p>
-            <a:pPr algn="l" indent="0" marL="0">
+            <a:pPr marL="0" indent="0" algn="l">
               <a:buNone/>
             </a:pPr>
             <a:r>
@@ -9162,7 +9341,7 @@
           <a:bodyPr wrap="square" lIns="0" tIns="0" rIns="0" bIns="0" rtlCol="0" anchor="ctr"/>
           <a:lstStyle/>
           <a:p>
-            <a:pPr algn="l" indent="0" marL="0">
+            <a:pPr marL="0" indent="0" algn="l">
               <a:buNone/>
             </a:pPr>
             <a:r>
@@ -9201,7 +9380,7 @@
           <a:bodyPr wrap="square" lIns="0" tIns="0" rIns="0" bIns="0" rtlCol="0" anchor="ctr"/>
           <a:lstStyle/>
           <a:p>
-            <a:pPr algn="l" indent="0" marL="0">
+            <a:pPr marL="0" indent="0" algn="l">
               <a:buNone/>
             </a:pPr>
             <a:r>
@@ -9240,7 +9419,7 @@
           <a:bodyPr wrap="square" lIns="0" tIns="0" rIns="0" bIns="0" rtlCol="0" anchor="ctr"/>
           <a:lstStyle/>
           <a:p>
-            <a:pPr algn="l" indent="0" marL="0">
+            <a:pPr marL="0" indent="0" algn="l">
               <a:buNone/>
             </a:pPr>
             <a:r>
@@ -9279,7 +9458,7 @@
           <a:bodyPr wrap="square" lIns="0" tIns="0" rIns="0" bIns="0" rtlCol="0" anchor="ctr"/>
           <a:lstStyle/>
           <a:p>
-            <a:pPr algn="l" indent="0" marL="0">
+            <a:pPr marL="0" indent="0" algn="l">
               <a:buNone/>
             </a:pPr>
             <a:r>
@@ -9318,7 +9497,7 @@
           <a:bodyPr wrap="square" lIns="0" tIns="0" rIns="0" bIns="0" rtlCol="0" anchor="ctr"/>
           <a:lstStyle/>
           <a:p>
-            <a:pPr algn="l" indent="0" marL="0">
+            <a:pPr marL="0" indent="0" algn="l">
               <a:buNone/>
             </a:pPr>
             <a:r>
@@ -9360,24 +9539,31 @@
             <a:prstDash val="solid"/>
           </a:ln>
           <a:effectLst>
-            <a:outerShdw sx="100000" sy="100000" kx="0" ky="0" algn="bl" rotWithShape="0" blurRad="114300" dist="38100" dir="5400000">
+            <a:outerShdw blurRad="114300" dist="38100" dir="5400000" algn="bl" rotWithShape="0">
               <a:srgbClr val="0A1430">
                 <a:alpha val="18000"/>
               </a:srgbClr>
             </a:outerShdw>
           </a:effectLst>
         </p:spPr>
+        <p:txBody>
+          <a:bodyPr/>
+          <a:lstStyle/>
+          <a:p>
+            <a:endParaRPr lang="ru-RU"/>
+          </a:p>
+        </p:txBody>
       </p:sp>
       <p:pic>
         <p:nvPicPr>
-          <p:cNvPr id="13" name="Image 0" descr="C:\Users\Kaiba\Desktop\study\project_attack_llm\results\figures\accuracy_curves.png">    </p:cNvPr>
+          <p:cNvPr id="13" name="Image 0" descr="C:\Users\Kaiba\Desktop\study\project_attack_llm\results\figures\accuracy_curves.png"/>
           <p:cNvPicPr>
             <a:picLocks noChangeAspect="1"/>
           </p:cNvPicPr>
           <p:nvPr/>
         </p:nvPicPr>
         <p:blipFill>
-          <a:blip r:embed="rId1"/>
+          <a:blip r:embed="rId3"/>
           <a:stretch>
             <a:fillRect/>
           </a:stretch>
@@ -9413,7 +9599,7 @@
           <a:bodyPr wrap="square" rtlCol="0" anchor="ctr"/>
           <a:lstStyle/>
           <a:p>
-            <a:pPr algn="ctr" indent="0" marL="0">
+            <a:pPr marL="0" indent="0" algn="ctr">
               <a:buNone/>
             </a:pPr>
             <a:r>
@@ -9732,4 +9918,319 @@
     </a:ext>
   </a:extLst>
 </a:theme>
+</file>
+
+<file path=ppt/theme/theme2.xml><?xml version="1.0" encoding="utf-8"?>
+<a:theme xmlns:a="http://schemas.openxmlformats.org/drawingml/2006/main" name="Тема Office">
+  <a:themeElements>
+    <a:clrScheme name="Стандартная">
+      <a:dk1>
+        <a:sysClr val="windowText" lastClr="000000"/>
+      </a:dk1>
+      <a:lt1>
+        <a:sysClr val="window" lastClr="FFFFFF"/>
+      </a:lt1>
+      <a:dk2>
+        <a:srgbClr val="0E2841"/>
+      </a:dk2>
+      <a:lt2>
+        <a:srgbClr val="E8E8E8"/>
+      </a:lt2>
+      <a:accent1>
+        <a:srgbClr val="156082"/>
+      </a:accent1>
+      <a:accent2>
+        <a:srgbClr val="E97132"/>
+      </a:accent2>
+      <a:accent3>
+        <a:srgbClr val="196B24"/>
+      </a:accent3>
+      <a:accent4>
+        <a:srgbClr val="0F9ED5"/>
+      </a:accent4>
+      <a:accent5>
+        <a:srgbClr val="A02B93"/>
+      </a:accent5>
+      <a:accent6>
+        <a:srgbClr val="4EA72E"/>
+      </a:accent6>
+      <a:hlink>
+        <a:srgbClr val="467886"/>
+      </a:hlink>
+      <a:folHlink>
+        <a:srgbClr val="96607D"/>
+      </a:folHlink>
+    </a:clrScheme>
+    <a:fontScheme name="Стандартная">
+      <a:majorFont>
+        <a:latin typeface="Aptos Display" panose="02110004020202020204"/>
+        <a:ea typeface=""/>
+        <a:cs typeface=""/>
+        <a:font script="Jpan" typeface="游ゴシック Light"/>
+        <a:font script="Hang" typeface="맑은 고딕"/>
+        <a:font script="Hans" typeface="等线 Light"/>
+        <a:font script="Hant" typeface="新細明體"/>
+        <a:font script="Arab" typeface="Times New Roman"/>
+        <a:font script="Hebr" typeface="Times New Roman"/>
+        <a:font script="Thai" typeface="Angsana New"/>
+        <a:font script="Ethi" typeface="Nyala"/>
+        <a:font script="Beng" typeface="Vrinda"/>
+        <a:font script="Gujr" typeface="Shruti"/>
+        <a:font script="Khmr" typeface="MoolBoran"/>
+        <a:font script="Knda" typeface="Tunga"/>
+        <a:font script="Guru" typeface="Raavi"/>
+        <a:font script="Cans" typeface="Euphemia"/>
+        <a:font script="Cher" typeface="Plantagenet Cherokee"/>
+        <a:font script="Yiii" typeface="Microsoft Yi Baiti"/>
+        <a:font script="Tibt" typeface="Microsoft Himalaya"/>
+        <a:font script="Thaa" typeface="MV Boli"/>
+        <a:font script="Deva" typeface="Mangal"/>
+        <a:font script="Telu" typeface="Gautami"/>
+        <a:font script="Taml" typeface="Latha"/>
+        <a:font script="Syrc" typeface="Estrangelo Edessa"/>
+        <a:font script="Orya" typeface="Kalinga"/>
+        <a:font script="Mlym" typeface="Kartika"/>
+        <a:font script="Laoo" typeface="DokChampa"/>
+        <a:font script="Sinh" typeface="Iskoola Pota"/>
+        <a:font script="Mong" typeface="Mongolian Baiti"/>
+        <a:font script="Viet" typeface="Times New Roman"/>
+        <a:font script="Uigh" typeface="Microsoft Uighur"/>
+        <a:font script="Geor" typeface="Sylfaen"/>
+        <a:font script="Armn" typeface="Arial"/>
+        <a:font script="Bugi" typeface="Leelawadee UI"/>
+        <a:font script="Bopo" typeface="Microsoft JhengHei"/>
+        <a:font script="Java" typeface="Javanese Text"/>
+        <a:font script="Lisu" typeface="Segoe UI"/>
+        <a:font script="Mymr" typeface="Myanmar Text"/>
+        <a:font script="Nkoo" typeface="Ebrima"/>
+        <a:font script="Olck" typeface="Nirmala UI"/>
+        <a:font script="Osma" typeface="Ebrima"/>
+        <a:font script="Phag" typeface="Phagspa"/>
+        <a:font script="Syrn" typeface="Estrangelo Edessa"/>
+        <a:font script="Syrj" typeface="Estrangelo Edessa"/>
+        <a:font script="Syre" typeface="Estrangelo Edessa"/>
+        <a:font script="Sora" typeface="Nirmala UI"/>
+        <a:font script="Tale" typeface="Microsoft Tai Le"/>
+        <a:font script="Talu" typeface="Microsoft New Tai Lue"/>
+        <a:font script="Tfng" typeface="Ebrima"/>
+      </a:majorFont>
+      <a:minorFont>
+        <a:latin typeface="Aptos" panose="02110004020202020204"/>
+        <a:ea typeface=""/>
+        <a:cs typeface=""/>
+        <a:font script="Jpan" typeface="游ゴシック"/>
+        <a:font script="Hang" typeface="맑은 고딕"/>
+        <a:font script="Hans" typeface="等线"/>
+        <a:font script="Hant" typeface="新細明體"/>
+        <a:font script="Arab" typeface="Arial"/>
+        <a:font script="Hebr" typeface="Arial"/>
+        <a:font script="Thai" typeface="Cordia New"/>
+        <a:font script="Ethi" typeface="Nyala"/>
+        <a:font script="Beng" typeface="Vrinda"/>
+        <a:font script="Gujr" typeface="Shruti"/>
+        <a:font script="Khmr" typeface="DaunPenh"/>
+        <a:font script="Knda" typeface="Tunga"/>
+        <a:font script="Guru" typeface="Raavi"/>
+        <a:font script="Cans" typeface="Euphemia"/>
+        <a:font script="Cher" typeface="Plantagenet Cherokee"/>
+        <a:font script="Yiii" typeface="Microsoft Yi Baiti"/>
+        <a:font script="Tibt" typeface="Microsoft Himalaya"/>
+        <a:font script="Thaa" typeface="MV Boli"/>
+        <a:font script="Deva" typeface="Mangal"/>
+        <a:font script="Telu" typeface="Gautami"/>
+        <a:font script="Taml" typeface="Latha"/>
+        <a:font script="Syrc" typeface="Estrangelo Edessa"/>
+        <a:font script="Orya" typeface="Kalinga"/>
+        <a:font script="Mlym" typeface="Kartika"/>
+        <a:font script="Laoo" typeface="DokChampa"/>
+        <a:font script="Sinh" typeface="Iskoola Pota"/>
+        <a:font script="Mong" typeface="Mongolian Baiti"/>
+        <a:font script="Viet" typeface="Arial"/>
+        <a:font script="Uigh" typeface="Microsoft Uighur"/>
+        <a:font script="Geor" typeface="Sylfaen"/>
+        <a:font script="Armn" typeface="Arial"/>
+        <a:font script="Bugi" typeface="Leelawadee UI"/>
+        <a:font script="Bopo" typeface="Microsoft JhengHei"/>
+        <a:font script="Java" typeface="Javanese Text"/>
+        <a:font script="Lisu" typeface="Segoe UI"/>
+        <a:font script="Mymr" typeface="Myanmar Text"/>
+        <a:font script="Nkoo" typeface="Ebrima"/>
+        <a:font script="Olck" typeface="Nirmala UI"/>
+        <a:font script="Osma" typeface="Ebrima"/>
+        <a:font script="Phag" typeface="Phagspa"/>
+        <a:font script="Syrn" typeface="Estrangelo Edessa"/>
+        <a:font script="Syrj" typeface="Estrangelo Edessa"/>
+        <a:font script="Syre" typeface="Estrangelo Edessa"/>
+        <a:font script="Sora" typeface="Nirmala UI"/>
+        <a:font script="Tale" typeface="Microsoft Tai Le"/>
+        <a:font script="Talu" typeface="Microsoft New Tai Lue"/>
+        <a:font script="Tfng" typeface="Ebrima"/>
+      </a:minorFont>
+    </a:fontScheme>
+    <a:fmtScheme name="Стандартная">
+      <a:fillStyleLst>
+        <a:solidFill>
+          <a:schemeClr val="phClr"/>
+        </a:solidFill>
+        <a:gradFill rotWithShape="1">
+          <a:gsLst>
+            <a:gs pos="0">
+              <a:schemeClr val="phClr">
+                <a:lumMod val="110000"/>
+                <a:satMod val="105000"/>
+                <a:tint val="67000"/>
+              </a:schemeClr>
+            </a:gs>
+            <a:gs pos="50000">
+              <a:schemeClr val="phClr">
+                <a:lumMod val="105000"/>
+                <a:satMod val="103000"/>
+                <a:tint val="73000"/>
+              </a:schemeClr>
+            </a:gs>
+            <a:gs pos="100000">
+              <a:schemeClr val="phClr">
+                <a:lumMod val="105000"/>
+                <a:satMod val="109000"/>
+                <a:tint val="81000"/>
+              </a:schemeClr>
+            </a:gs>
+          </a:gsLst>
+          <a:lin ang="5400000" scaled="0"/>
+        </a:gradFill>
+        <a:gradFill rotWithShape="1">
+          <a:gsLst>
+            <a:gs pos="0">
+              <a:schemeClr val="phClr">
+                <a:satMod val="103000"/>
+                <a:lumMod val="102000"/>
+                <a:tint val="94000"/>
+              </a:schemeClr>
+            </a:gs>
+            <a:gs pos="50000">
+              <a:schemeClr val="phClr">
+                <a:satMod val="110000"/>
+                <a:lumMod val="100000"/>
+                <a:shade val="100000"/>
+              </a:schemeClr>
+            </a:gs>
+            <a:gs pos="100000">
+              <a:schemeClr val="phClr">
+                <a:lumMod val="99000"/>
+                <a:satMod val="120000"/>
+                <a:shade val="78000"/>
+              </a:schemeClr>
+            </a:gs>
+          </a:gsLst>
+          <a:lin ang="5400000" scaled="0"/>
+        </a:gradFill>
+      </a:fillStyleLst>
+      <a:lnStyleLst>
+        <a:ln w="12700" cap="flat" cmpd="sng" algn="ctr">
+          <a:solidFill>
+            <a:schemeClr val="phClr"/>
+          </a:solidFill>
+          <a:prstDash val="solid"/>
+          <a:miter lim="800000"/>
+        </a:ln>
+        <a:ln w="19050" cap="flat" cmpd="sng" algn="ctr">
+          <a:solidFill>
+            <a:schemeClr val="phClr"/>
+          </a:solidFill>
+          <a:prstDash val="solid"/>
+          <a:miter lim="800000"/>
+        </a:ln>
+        <a:ln w="25400" cap="flat" cmpd="sng" algn="ctr">
+          <a:solidFill>
+            <a:schemeClr val="phClr"/>
+          </a:solidFill>
+          <a:prstDash val="solid"/>
+          <a:miter lim="800000"/>
+        </a:ln>
+      </a:lnStyleLst>
+      <a:effectStyleLst>
+        <a:effectStyle>
+          <a:effectLst/>
+        </a:effectStyle>
+        <a:effectStyle>
+          <a:effectLst/>
+        </a:effectStyle>
+        <a:effectStyle>
+          <a:effectLst>
+            <a:outerShdw blurRad="57150" dist="19050" dir="5400000" algn="ctr" rotWithShape="0">
+              <a:srgbClr val="000000">
+                <a:alpha val="63000"/>
+              </a:srgbClr>
+            </a:outerShdw>
+          </a:effectLst>
+        </a:effectStyle>
+      </a:effectStyleLst>
+      <a:bgFillStyleLst>
+        <a:solidFill>
+          <a:schemeClr val="phClr"/>
+        </a:solidFill>
+        <a:solidFill>
+          <a:schemeClr val="phClr">
+            <a:tint val="95000"/>
+            <a:satMod val="170000"/>
+          </a:schemeClr>
+        </a:solidFill>
+        <a:gradFill rotWithShape="1">
+          <a:gsLst>
+            <a:gs pos="0">
+              <a:schemeClr val="phClr">
+                <a:tint val="93000"/>
+                <a:satMod val="150000"/>
+                <a:shade val="98000"/>
+                <a:lumMod val="102000"/>
+              </a:schemeClr>
+            </a:gs>
+            <a:gs pos="50000">
+              <a:schemeClr val="phClr">
+                <a:tint val="98000"/>
+                <a:satMod val="130000"/>
+                <a:shade val="90000"/>
+                <a:lumMod val="103000"/>
+              </a:schemeClr>
+            </a:gs>
+            <a:gs pos="100000">
+              <a:schemeClr val="phClr">
+                <a:shade val="63000"/>
+                <a:satMod val="120000"/>
+              </a:schemeClr>
+            </a:gs>
+          </a:gsLst>
+          <a:lin ang="5400000" scaled="0"/>
+        </a:gradFill>
+      </a:bgFillStyleLst>
+    </a:fmtScheme>
+  </a:themeElements>
+  <a:objectDefaults>
+    <a:lnDef>
+      <a:spPr/>
+      <a:bodyPr/>
+      <a:lstStyle/>
+      <a:style>
+        <a:lnRef idx="2">
+          <a:schemeClr val="accent1"/>
+        </a:lnRef>
+        <a:fillRef idx="0">
+          <a:schemeClr val="accent1"/>
+        </a:fillRef>
+        <a:effectRef idx="1">
+          <a:schemeClr val="accent1"/>
+        </a:effectRef>
+        <a:fontRef idx="minor">
+          <a:schemeClr val="tx1"/>
+        </a:fontRef>
+      </a:style>
+    </a:lnDef>
+  </a:objectDefaults>
+  <a:extraClrSchemeLst/>
+  <a:extLst>
+    <a:ext uri="{05A4C25C-085E-4340-85A3-A5531E510DB2}">
+      <thm15:themeFamily xmlns:thm15="http://schemas.microsoft.com/office/thememl/2012/main" name="Office Theme" id="{2E142A2C-CD16-42D6-873A-C26D2A0506FA}" vid="{1BDDFF52-6CD6-40A5-AB3C-68EB2F1E4D0A}"/>
+    </a:ext>
+  </a:extLst>
+</a:theme>
 </file>
</xml_diff>